<commit_message>
Clean project and keep datasets local
Made-with: Cursor
</commit_message>
<xml_diff>
--- a/УУУУ.pptx
+++ b/УУУУ.pptx
@@ -5,15 +5,19 @@
     <p:sldMasterId id="2147483648" r:id="rId1"/>
   </p:sldMasterIdLst>
   <p:notesMasterIdLst>
-    <p:notesMasterId r:id="rId8"/>
+    <p:notesMasterId r:id="rId12"/>
   </p:notesMasterIdLst>
   <p:sldIdLst>
     <p:sldId id="256" r:id="rId2"/>
     <p:sldId id="259" r:id="rId3"/>
     <p:sldId id="258" r:id="rId4"/>
-    <p:sldId id="260" r:id="rId5"/>
-    <p:sldId id="261" r:id="rId6"/>
-    <p:sldId id="257" r:id="rId7"/>
+    <p:sldId id="265" r:id="rId5"/>
+    <p:sldId id="260" r:id="rId6"/>
+    <p:sldId id="261" r:id="rId7"/>
+    <p:sldId id="262" r:id="rId8"/>
+    <p:sldId id="263" r:id="rId9"/>
+    <p:sldId id="264" r:id="rId10"/>
+    <p:sldId id="257" r:id="rId11"/>
   </p:sldIdLst>
   <p:sldSz cx="12192000" cy="6858000"/>
   <p:notesSz cx="6858000" cy="9144000"/>
@@ -112,6 +116,11 @@
       </a:defRPr>
     </a:lvl9pPr>
   </p:defaultTextStyle>
+  <p:extLst>
+    <p:ext uri="{EFAFB233-063F-42B5-8137-9DF3F51BA10A}">
+      <p15:sldGuideLst xmlns:p15="http://schemas.microsoft.com/office/powerpoint/2012/main"/>
+    </p:ext>
+  </p:extLst>
 </p:presentation>
 </file>
 
@@ -197,7 +206,7 @@
           <a:p>
             <a:fld id="{DB8D0D4F-A8C0-42CC-8FCC-C2CCF1113BB7}" type="datetimeFigureOut">
               <a:rPr lang="en-US" smtClean="0"/>
-              <a:t>3/6/2026</a:t>
+              <a:t>4/10/2026</a:t>
             </a:fld>
             <a:endParaRPr lang="en-US"/>
           </a:p>
@@ -698,7 +707,7 @@
           <a:p>
             <a:fld id="{5425730C-8864-4307-8830-901534072DCD}" type="datetimeFigureOut">
               <a:rPr lang="en-US" smtClean="0"/>
-              <a:t>3/6/2026</a:t>
+              <a:t>4/10/2026</a:t>
             </a:fld>
             <a:endParaRPr lang="en-US"/>
           </a:p>
@@ -898,7 +907,7 @@
           <a:p>
             <a:fld id="{5425730C-8864-4307-8830-901534072DCD}" type="datetimeFigureOut">
               <a:rPr lang="en-US" smtClean="0"/>
-              <a:t>3/6/2026</a:t>
+              <a:t>4/10/2026</a:t>
             </a:fld>
             <a:endParaRPr lang="en-US"/>
           </a:p>
@@ -1108,7 +1117,7 @@
           <a:p>
             <a:fld id="{5425730C-8864-4307-8830-901534072DCD}" type="datetimeFigureOut">
               <a:rPr lang="en-US" smtClean="0"/>
-              <a:t>3/6/2026</a:t>
+              <a:t>4/10/2026</a:t>
             </a:fld>
             <a:endParaRPr lang="en-US"/>
           </a:p>
@@ -1308,7 +1317,7 @@
           <a:p>
             <a:fld id="{5425730C-8864-4307-8830-901534072DCD}" type="datetimeFigureOut">
               <a:rPr lang="en-US" smtClean="0"/>
-              <a:t>3/6/2026</a:t>
+              <a:t>4/10/2026</a:t>
             </a:fld>
             <a:endParaRPr lang="en-US"/>
           </a:p>
@@ -1584,7 +1593,7 @@
           <a:p>
             <a:fld id="{5425730C-8864-4307-8830-901534072DCD}" type="datetimeFigureOut">
               <a:rPr lang="en-US" smtClean="0"/>
-              <a:t>3/6/2026</a:t>
+              <a:t>4/10/2026</a:t>
             </a:fld>
             <a:endParaRPr lang="en-US"/>
           </a:p>
@@ -1852,7 +1861,7 @@
           <a:p>
             <a:fld id="{5425730C-8864-4307-8830-901534072DCD}" type="datetimeFigureOut">
               <a:rPr lang="en-US" smtClean="0"/>
-              <a:t>3/6/2026</a:t>
+              <a:t>4/10/2026</a:t>
             </a:fld>
             <a:endParaRPr lang="en-US"/>
           </a:p>
@@ -2267,7 +2276,7 @@
           <a:p>
             <a:fld id="{5425730C-8864-4307-8830-901534072DCD}" type="datetimeFigureOut">
               <a:rPr lang="en-US" smtClean="0"/>
-              <a:t>3/6/2026</a:t>
+              <a:t>4/10/2026</a:t>
             </a:fld>
             <a:endParaRPr lang="en-US"/>
           </a:p>
@@ -2409,7 +2418,7 @@
           <a:p>
             <a:fld id="{5425730C-8864-4307-8830-901534072DCD}" type="datetimeFigureOut">
               <a:rPr lang="en-US" smtClean="0"/>
-              <a:t>3/6/2026</a:t>
+              <a:t>4/10/2026</a:t>
             </a:fld>
             <a:endParaRPr lang="en-US"/>
           </a:p>
@@ -2522,7 +2531,7 @@
           <a:p>
             <a:fld id="{5425730C-8864-4307-8830-901534072DCD}" type="datetimeFigureOut">
               <a:rPr lang="en-US" smtClean="0"/>
-              <a:t>3/6/2026</a:t>
+              <a:t>4/10/2026</a:t>
             </a:fld>
             <a:endParaRPr lang="en-US"/>
           </a:p>
@@ -2835,7 +2844,7 @@
           <a:p>
             <a:fld id="{5425730C-8864-4307-8830-901534072DCD}" type="datetimeFigureOut">
               <a:rPr lang="en-US" smtClean="0"/>
-              <a:t>3/6/2026</a:t>
+              <a:t>4/10/2026</a:t>
             </a:fld>
             <a:endParaRPr lang="en-US"/>
           </a:p>
@@ -3124,7 +3133,7 @@
           <a:p>
             <a:fld id="{5425730C-8864-4307-8830-901534072DCD}" type="datetimeFigureOut">
               <a:rPr lang="en-US" smtClean="0"/>
-              <a:t>3/6/2026</a:t>
+              <a:t>4/10/2026</a:t>
             </a:fld>
             <a:endParaRPr lang="en-US"/>
           </a:p>
@@ -3367,7 +3376,7 @@
           <a:p>
             <a:fld id="{5425730C-8864-4307-8830-901534072DCD}" type="datetimeFigureOut">
               <a:rPr lang="en-US" smtClean="0"/>
-              <a:t>3/6/2026</a:t>
+              <a:t>4/10/2026</a:t>
             </a:fld>
             <a:endParaRPr lang="en-US"/>
           </a:p>
@@ -4055,10 +4064,833 @@
           </a:fontRef>
         </p:style>
       </p:cxnSp>
+      <p:sp>
+        <p:nvSpPr>
+          <p:cNvPr id="10" name="Прямоугольник: скругленные углы 9">
+            <a:extLst>
+              <a:ext uri="{FF2B5EF4-FFF2-40B4-BE49-F238E27FC236}">
+                <a16:creationId xmlns:a16="http://schemas.microsoft.com/office/drawing/2014/main" id="{D7DF113B-F2D3-A2AE-02B9-07E7EAFD4291}"/>
+              </a:ext>
+            </a:extLst>
+          </p:cNvPr>
+          <p:cNvSpPr/>
+          <p:nvPr/>
+        </p:nvSpPr>
+        <p:spPr>
+          <a:xfrm>
+            <a:off x="125088" y="107690"/>
+            <a:ext cx="751498" cy="752789"/>
+          </a:xfrm>
+          <a:prstGeom prst="roundRect">
+            <a:avLst>
+              <a:gd name="adj" fmla="val 2225"/>
+            </a:avLst>
+          </a:prstGeom>
+          <a:solidFill>
+            <a:srgbClr val="990F0F"/>
+          </a:solidFill>
+          <a:ln>
+            <a:noFill/>
+          </a:ln>
+        </p:spPr>
+        <p:style>
+          <a:lnRef idx="2">
+            <a:schemeClr val="accent1">
+              <a:shade val="15000"/>
+            </a:schemeClr>
+          </a:lnRef>
+          <a:fillRef idx="1">
+            <a:schemeClr val="accent1"/>
+          </a:fillRef>
+          <a:effectRef idx="0">
+            <a:schemeClr val="accent1"/>
+          </a:effectRef>
+          <a:fontRef idx="minor">
+            <a:schemeClr val="lt1"/>
+          </a:fontRef>
+        </p:style>
+        <p:txBody>
+          <a:bodyPr rtlCol="0" anchor="ctr"/>
+          <a:lstStyle/>
+          <a:p>
+            <a:pPr algn="ctr"/>
+            <a:endParaRPr lang="en-US"/>
+          </a:p>
+        </p:txBody>
+      </p:sp>
+      <p:pic>
+        <p:nvPicPr>
+          <p:cNvPr id="9" name="Рисунок 8">
+            <a:extLst>
+              <a:ext uri="{FF2B5EF4-FFF2-40B4-BE49-F238E27FC236}">
+                <a16:creationId xmlns:a16="http://schemas.microsoft.com/office/drawing/2014/main" id="{6AFC0819-F956-B9E4-F081-4DBAC07B0D00}"/>
+              </a:ext>
+            </a:extLst>
+          </p:cNvPr>
+          <p:cNvPicPr>
+            <a:picLocks noChangeAspect="1"/>
+          </p:cNvPicPr>
+          <p:nvPr/>
+        </p:nvPicPr>
+        <p:blipFill>
+          <a:blip r:embed="rId4"/>
+          <a:stretch>
+            <a:fillRect/>
+          </a:stretch>
+        </p:blipFill>
+        <p:spPr>
+          <a:xfrm>
+            <a:off x="144685" y="127321"/>
+            <a:ext cx="712304" cy="713528"/>
+          </a:xfrm>
+          <a:prstGeom prst="rect">
+            <a:avLst/>
+          </a:prstGeom>
+          <a:effectLst>
+            <a:softEdge rad="0"/>
+          </a:effectLst>
+        </p:spPr>
+      </p:pic>
     </p:spTree>
     <p:extLst>
       <p:ext uri="{BB962C8B-B14F-4D97-AF65-F5344CB8AC3E}">
         <p14:creationId xmlns:p14="http://schemas.microsoft.com/office/powerpoint/2010/main" val="224080055"/>
+      </p:ext>
+    </p:extLst>
+  </p:cSld>
+  <p:clrMapOvr>
+    <a:masterClrMapping/>
+  </p:clrMapOvr>
+</p:sld>
+</file>
+
+<file path=ppt/slides/slide10.xml><?xml version="1.0" encoding="utf-8"?>
+<p:sld xmlns:a="http://schemas.openxmlformats.org/drawingml/2006/main" xmlns:r="http://schemas.openxmlformats.org/officeDocument/2006/relationships" xmlns:p="http://schemas.openxmlformats.org/presentationml/2006/main">
+  <p:cSld>
+    <p:spTree>
+      <p:nvGrpSpPr>
+        <p:cNvPr id="1" name=""/>
+        <p:cNvGrpSpPr/>
+        <p:nvPr/>
+      </p:nvGrpSpPr>
+      <p:grpSpPr>
+        <a:xfrm>
+          <a:off x="0" y="0"/>
+          <a:ext cx="0" cy="0"/>
+          <a:chOff x="0" y="0"/>
+          <a:chExt cx="0" cy="0"/>
+        </a:xfrm>
+      </p:grpSpPr>
+      <p:sp>
+        <p:nvSpPr>
+          <p:cNvPr id="3" name="TextBox 2">
+            <a:extLst>
+              <a:ext uri="{FF2B5EF4-FFF2-40B4-BE49-F238E27FC236}">
+                <a16:creationId xmlns:a16="http://schemas.microsoft.com/office/drawing/2014/main" id="{A7E884D9-E79E-7E1E-FDD1-286C1D46C3B9}"/>
+              </a:ext>
+            </a:extLst>
+          </p:cNvPr>
+          <p:cNvSpPr txBox="1"/>
+          <p:nvPr/>
+        </p:nvSpPr>
+        <p:spPr>
+          <a:xfrm>
+            <a:off x="5346202" y="286090"/>
+            <a:ext cx="1499594" cy="646331"/>
+          </a:xfrm>
+          <a:prstGeom prst="rect">
+            <a:avLst/>
+          </a:prstGeom>
+          <a:noFill/>
+        </p:spPr>
+        <p:txBody>
+          <a:bodyPr wrap="square">
+            <a:spAutoFit/>
+          </a:bodyPr>
+          <a:lstStyle/>
+          <a:p>
+            <a:r>
+              <a:rPr lang="ru-RU" sz="3600" b="1" dirty="0">
+                <a:latin typeface="GOST type A" panose="020B0500000000000000" pitchFamily="34" charset="0"/>
+              </a:rPr>
+              <a:t>Команда</a:t>
+            </a:r>
+            <a:endParaRPr lang="en-US" sz="3600" b="1" dirty="0">
+              <a:latin typeface="GOST type A" panose="020B0500000000000000" pitchFamily="34" charset="0"/>
+            </a:endParaRPr>
+          </a:p>
+        </p:txBody>
+      </p:sp>
+      <p:pic>
+        <p:nvPicPr>
+          <p:cNvPr id="10" name="Рисунок 9">
+            <a:extLst>
+              <a:ext uri="{FF2B5EF4-FFF2-40B4-BE49-F238E27FC236}">
+                <a16:creationId xmlns:a16="http://schemas.microsoft.com/office/drawing/2014/main" id="{53A4030D-DC26-D362-7D58-B207E38D8535}"/>
+              </a:ext>
+            </a:extLst>
+          </p:cNvPr>
+          <p:cNvPicPr>
+            <a:picLocks noChangeAspect="1"/>
+          </p:cNvPicPr>
+          <p:nvPr/>
+        </p:nvPicPr>
+        <p:blipFill>
+          <a:blip r:embed="rId2">
+            <a:extLst>
+              <a:ext uri="{28A0092B-C50C-407E-A947-70E740481C1C}">
+                <a14:useLocalDpi xmlns:a14="http://schemas.microsoft.com/office/drawing/2010/main" val="0"/>
+              </a:ext>
+            </a:extLst>
+          </a:blip>
+          <a:srcRect/>
+          <a:stretch>
+            <a:fillRect/>
+          </a:stretch>
+        </p:blipFill>
+        <p:spPr>
+          <a:xfrm>
+            <a:off x="1927938" y="1518126"/>
+            <a:ext cx="2988365" cy="2988365"/>
+          </a:xfrm>
+          <a:custGeom>
+            <a:avLst/>
+            <a:gdLst>
+              <a:gd name="csX0" fmla="*/ 1494163 w 2988365"/>
+              <a:gd name="csY0" fmla="*/ 0 h 2988365"/>
+              <a:gd name="csX1" fmla="*/ 1494204 w 2988365"/>
+              <a:gd name="csY1" fmla="*/ 0 h 2988365"/>
+              <a:gd name="csX2" fmla="*/ 1646955 w 2988365"/>
+              <a:gd name="csY2" fmla="*/ 7713 h 2988365"/>
+              <a:gd name="csX3" fmla="*/ 2980652 w 2988365"/>
+              <a:gd name="csY3" fmla="*/ 1341411 h 2988365"/>
+              <a:gd name="csX4" fmla="*/ 2988365 w 2988365"/>
+              <a:gd name="csY4" fmla="*/ 1494163 h 2988365"/>
+              <a:gd name="csX5" fmla="*/ 2988365 w 2988365"/>
+              <a:gd name="csY5" fmla="*/ 1494202 h 2988365"/>
+              <a:gd name="csX6" fmla="*/ 2980652 w 2988365"/>
+              <a:gd name="csY6" fmla="*/ 1646954 h 2988365"/>
+              <a:gd name="csX7" fmla="*/ 1494183 w 2988365"/>
+              <a:gd name="csY7" fmla="*/ 2988365 h 2988365"/>
+              <a:gd name="csX8" fmla="*/ 0 w 2988365"/>
+              <a:gd name="csY8" fmla="*/ 1494182 h 2988365"/>
+              <a:gd name="csX9" fmla="*/ 1341412 w 2988365"/>
+              <a:gd name="csY9" fmla="*/ 7713 h 2988365"/>
+            </a:gdLst>
+            <a:ahLst/>
+            <a:cxnLst>
+              <a:cxn ang="0">
+                <a:pos x="csX0" y="csY0"/>
+              </a:cxn>
+              <a:cxn ang="0">
+                <a:pos x="csX1" y="csY1"/>
+              </a:cxn>
+              <a:cxn ang="0">
+                <a:pos x="csX2" y="csY2"/>
+              </a:cxn>
+              <a:cxn ang="0">
+                <a:pos x="csX3" y="csY3"/>
+              </a:cxn>
+              <a:cxn ang="0">
+                <a:pos x="csX4" y="csY4"/>
+              </a:cxn>
+              <a:cxn ang="0">
+                <a:pos x="csX5" y="csY5"/>
+              </a:cxn>
+              <a:cxn ang="0">
+                <a:pos x="csX6" y="csY6"/>
+              </a:cxn>
+              <a:cxn ang="0">
+                <a:pos x="csX7" y="csY7"/>
+              </a:cxn>
+              <a:cxn ang="0">
+                <a:pos x="csX8" y="csY8"/>
+              </a:cxn>
+              <a:cxn ang="0">
+                <a:pos x="csX9" y="csY9"/>
+              </a:cxn>
+            </a:cxnLst>
+            <a:rect l="l" t="t" r="r" b="b"/>
+            <a:pathLst>
+              <a:path w="2988365" h="2988365">
+                <a:moveTo>
+                  <a:pt x="1494163" y="0"/>
+                </a:moveTo>
+                <a:lnTo>
+                  <a:pt x="1494204" y="0"/>
+                </a:lnTo>
+                <a:lnTo>
+                  <a:pt x="1646955" y="7713"/>
+                </a:lnTo>
+                <a:cubicBezTo>
+                  <a:pt x="2350175" y="79129"/>
+                  <a:pt x="2909236" y="638190"/>
+                  <a:pt x="2980652" y="1341411"/>
+                </a:cubicBezTo>
+                <a:lnTo>
+                  <a:pt x="2988365" y="1494163"/>
+                </a:lnTo>
+                <a:lnTo>
+                  <a:pt x="2988365" y="1494202"/>
+                </a:lnTo>
+                <a:lnTo>
+                  <a:pt x="2980652" y="1646954"/>
+                </a:lnTo>
+                <a:cubicBezTo>
+                  <a:pt x="2904135" y="2400404"/>
+                  <a:pt x="2267821" y="2988365"/>
+                  <a:pt x="1494183" y="2988365"/>
+                </a:cubicBezTo>
+                <a:cubicBezTo>
+                  <a:pt x="668969" y="2988365"/>
+                  <a:pt x="0" y="2319396"/>
+                  <a:pt x="0" y="1494182"/>
+                </a:cubicBezTo>
+                <a:cubicBezTo>
+                  <a:pt x="0" y="720544"/>
+                  <a:pt x="587961" y="84231"/>
+                  <a:pt x="1341412" y="7713"/>
+                </a:cubicBezTo>
+                <a:close/>
+              </a:path>
+            </a:pathLst>
+          </a:custGeom>
+        </p:spPr>
+      </p:pic>
+      <p:pic>
+        <p:nvPicPr>
+          <p:cNvPr id="14" name="Рисунок 13">
+            <a:extLst>
+              <a:ext uri="{FF2B5EF4-FFF2-40B4-BE49-F238E27FC236}">
+                <a16:creationId xmlns:a16="http://schemas.microsoft.com/office/drawing/2014/main" id="{1FC942D5-4FD6-AC52-96D2-29F45352E8F1}"/>
+              </a:ext>
+            </a:extLst>
+          </p:cNvPr>
+          <p:cNvPicPr>
+            <a:picLocks noChangeAspect="1"/>
+          </p:cNvPicPr>
+          <p:nvPr/>
+        </p:nvPicPr>
+        <p:blipFill>
+          <a:blip r:embed="rId3"/>
+          <a:srcRect/>
+          <a:stretch>
+            <a:fillRect/>
+          </a:stretch>
+        </p:blipFill>
+        <p:spPr>
+          <a:xfrm>
+            <a:off x="6947131" y="1552851"/>
+            <a:ext cx="2988364" cy="2988365"/>
+          </a:xfrm>
+          <a:custGeom>
+            <a:avLst/>
+            <a:gdLst>
+              <a:gd name="csX0" fmla="*/ 1494163 w 2988364"/>
+              <a:gd name="csY0" fmla="*/ 0 h 2988365"/>
+              <a:gd name="csX1" fmla="*/ 1494204 w 2988364"/>
+              <a:gd name="csY1" fmla="*/ 0 h 2988365"/>
+              <a:gd name="csX2" fmla="*/ 1646955 w 2988364"/>
+              <a:gd name="csY2" fmla="*/ 7713 h 2988365"/>
+              <a:gd name="csX3" fmla="*/ 2980652 w 2988364"/>
+              <a:gd name="csY3" fmla="*/ 1341411 h 2988365"/>
+              <a:gd name="csX4" fmla="*/ 2988364 w 2988364"/>
+              <a:gd name="csY4" fmla="*/ 1494144 h 2988365"/>
+              <a:gd name="csX5" fmla="*/ 2988364 w 2988364"/>
+              <a:gd name="csY5" fmla="*/ 1494222 h 2988365"/>
+              <a:gd name="csX6" fmla="*/ 2980652 w 2988364"/>
+              <a:gd name="csY6" fmla="*/ 1646954 h 2988365"/>
+              <a:gd name="csX7" fmla="*/ 1494183 w 2988364"/>
+              <a:gd name="csY7" fmla="*/ 2988365 h 2988365"/>
+              <a:gd name="csX8" fmla="*/ 0 w 2988364"/>
+              <a:gd name="csY8" fmla="*/ 1494182 h 2988365"/>
+              <a:gd name="csX9" fmla="*/ 1341412 w 2988364"/>
+              <a:gd name="csY9" fmla="*/ 7713 h 2988365"/>
+            </a:gdLst>
+            <a:ahLst/>
+            <a:cxnLst>
+              <a:cxn ang="0">
+                <a:pos x="csX0" y="csY0"/>
+              </a:cxn>
+              <a:cxn ang="0">
+                <a:pos x="csX1" y="csY1"/>
+              </a:cxn>
+              <a:cxn ang="0">
+                <a:pos x="csX2" y="csY2"/>
+              </a:cxn>
+              <a:cxn ang="0">
+                <a:pos x="csX3" y="csY3"/>
+              </a:cxn>
+              <a:cxn ang="0">
+                <a:pos x="csX4" y="csY4"/>
+              </a:cxn>
+              <a:cxn ang="0">
+                <a:pos x="csX5" y="csY5"/>
+              </a:cxn>
+              <a:cxn ang="0">
+                <a:pos x="csX6" y="csY6"/>
+              </a:cxn>
+              <a:cxn ang="0">
+                <a:pos x="csX7" y="csY7"/>
+              </a:cxn>
+              <a:cxn ang="0">
+                <a:pos x="csX8" y="csY8"/>
+              </a:cxn>
+              <a:cxn ang="0">
+                <a:pos x="csX9" y="csY9"/>
+              </a:cxn>
+            </a:cxnLst>
+            <a:rect l="l" t="t" r="r" b="b"/>
+            <a:pathLst>
+              <a:path w="2988364" h="2988365">
+                <a:moveTo>
+                  <a:pt x="1494163" y="0"/>
+                </a:moveTo>
+                <a:lnTo>
+                  <a:pt x="1494204" y="0"/>
+                </a:lnTo>
+                <a:lnTo>
+                  <a:pt x="1646955" y="7713"/>
+                </a:lnTo>
+                <a:cubicBezTo>
+                  <a:pt x="2350175" y="79129"/>
+                  <a:pt x="2909236" y="638190"/>
+                  <a:pt x="2980652" y="1341411"/>
+                </a:cubicBezTo>
+                <a:lnTo>
+                  <a:pt x="2988364" y="1494144"/>
+                </a:lnTo>
+                <a:lnTo>
+                  <a:pt x="2988364" y="1494222"/>
+                </a:lnTo>
+                <a:lnTo>
+                  <a:pt x="2980652" y="1646954"/>
+                </a:lnTo>
+                <a:cubicBezTo>
+                  <a:pt x="2904135" y="2400404"/>
+                  <a:pt x="2267821" y="2988365"/>
+                  <a:pt x="1494183" y="2988365"/>
+                </a:cubicBezTo>
+                <a:cubicBezTo>
+                  <a:pt x="668969" y="2988365"/>
+                  <a:pt x="0" y="2319396"/>
+                  <a:pt x="0" y="1494182"/>
+                </a:cubicBezTo>
+                <a:cubicBezTo>
+                  <a:pt x="0" y="720544"/>
+                  <a:pt x="587961" y="84231"/>
+                  <a:pt x="1341412" y="7713"/>
+                </a:cubicBezTo>
+                <a:close/>
+              </a:path>
+            </a:pathLst>
+          </a:custGeom>
+        </p:spPr>
+      </p:pic>
+      <p:sp>
+        <p:nvSpPr>
+          <p:cNvPr id="17" name="TextBox 16">
+            <a:extLst>
+              <a:ext uri="{FF2B5EF4-FFF2-40B4-BE49-F238E27FC236}">
+                <a16:creationId xmlns:a16="http://schemas.microsoft.com/office/drawing/2014/main" id="{6C4F2015-6597-59CD-8024-2D1B0DABAFD5}"/>
+              </a:ext>
+            </a:extLst>
+          </p:cNvPr>
+          <p:cNvSpPr txBox="1"/>
+          <p:nvPr/>
+        </p:nvSpPr>
+        <p:spPr>
+          <a:xfrm>
+            <a:off x="2207999" y="4819005"/>
+            <a:ext cx="2491323" cy="461665"/>
+          </a:xfrm>
+          <a:prstGeom prst="rect">
+            <a:avLst/>
+          </a:prstGeom>
+          <a:noFill/>
+        </p:spPr>
+        <p:txBody>
+          <a:bodyPr wrap="square">
+            <a:spAutoFit/>
+          </a:bodyPr>
+          <a:lstStyle/>
+          <a:p>
+            <a:r>
+              <a:rPr lang="ru-RU" sz="2400" dirty="0">
+                <a:latin typeface="GOST type A" panose="020B0500000000000000" pitchFamily="34" charset="0"/>
+              </a:rPr>
+              <a:t>Смирнова Анастасия</a:t>
+            </a:r>
+            <a:endParaRPr lang="en-US" sz="2400" dirty="0">
+              <a:latin typeface="GOST type A" panose="020B0500000000000000" pitchFamily="34" charset="0"/>
+            </a:endParaRPr>
+          </a:p>
+        </p:txBody>
+      </p:sp>
+      <p:sp>
+        <p:nvSpPr>
+          <p:cNvPr id="19" name="TextBox 18">
+            <a:extLst>
+              <a:ext uri="{FF2B5EF4-FFF2-40B4-BE49-F238E27FC236}">
+                <a16:creationId xmlns:a16="http://schemas.microsoft.com/office/drawing/2014/main" id="{1B51DC4F-23D4-1220-816F-8FE7B607DDC5}"/>
+              </a:ext>
+            </a:extLst>
+          </p:cNvPr>
+          <p:cNvSpPr txBox="1"/>
+          <p:nvPr/>
+        </p:nvSpPr>
+        <p:spPr>
+          <a:xfrm>
+            <a:off x="7521932" y="4853729"/>
+            <a:ext cx="1988722" cy="461665"/>
+          </a:xfrm>
+          <a:prstGeom prst="rect">
+            <a:avLst/>
+          </a:prstGeom>
+          <a:noFill/>
+        </p:spPr>
+        <p:txBody>
+          <a:bodyPr wrap="square">
+            <a:spAutoFit/>
+          </a:bodyPr>
+          <a:lstStyle/>
+          <a:p>
+            <a:r>
+              <a:rPr lang="ru-RU" sz="2400" dirty="0">
+                <a:latin typeface="GOST type A" panose="020B0500000000000000" pitchFamily="34" charset="0"/>
+              </a:rPr>
+              <a:t>Морозова Софья</a:t>
+            </a:r>
+            <a:endParaRPr lang="en-US" sz="2400" dirty="0">
+              <a:latin typeface="GOST type A" panose="020B0500000000000000" pitchFamily="34" charset="0"/>
+            </a:endParaRPr>
+          </a:p>
+        </p:txBody>
+      </p:sp>
+      <p:sp>
+        <p:nvSpPr>
+          <p:cNvPr id="20" name="Овал 19">
+            <a:extLst>
+              <a:ext uri="{FF2B5EF4-FFF2-40B4-BE49-F238E27FC236}">
+                <a16:creationId xmlns:a16="http://schemas.microsoft.com/office/drawing/2014/main" id="{0CEC7A96-2EE1-7697-F92D-EB913742AF4A}"/>
+              </a:ext>
+            </a:extLst>
+          </p:cNvPr>
+          <p:cNvSpPr/>
+          <p:nvPr/>
+        </p:nvSpPr>
+        <p:spPr>
+          <a:xfrm>
+            <a:off x="1761153" y="1340814"/>
+            <a:ext cx="3321934" cy="3321934"/>
+          </a:xfrm>
+          <a:custGeom>
+            <a:avLst/>
+            <a:gdLst>
+              <a:gd name="csX0" fmla="*/ 0 w 3321934"/>
+              <a:gd name="csY0" fmla="*/ 1660967 h 3321934"/>
+              <a:gd name="csX1" fmla="*/ 1660967 w 3321934"/>
+              <a:gd name="csY1" fmla="*/ 0 h 3321934"/>
+              <a:gd name="csX2" fmla="*/ 3321934 w 3321934"/>
+              <a:gd name="csY2" fmla="*/ 1660967 h 3321934"/>
+              <a:gd name="csX3" fmla="*/ 1660967 w 3321934"/>
+              <a:gd name="csY3" fmla="*/ 3321934 h 3321934"/>
+              <a:gd name="csX4" fmla="*/ 0 w 3321934"/>
+              <a:gd name="csY4" fmla="*/ 1660967 h 3321934"/>
+            </a:gdLst>
+            <a:ahLst/>
+            <a:cxnLst>
+              <a:cxn ang="0">
+                <a:pos x="csX0" y="csY0"/>
+              </a:cxn>
+              <a:cxn ang="0">
+                <a:pos x="csX1" y="csY1"/>
+              </a:cxn>
+              <a:cxn ang="0">
+                <a:pos x="csX2" y="csY2"/>
+              </a:cxn>
+              <a:cxn ang="0">
+                <a:pos x="csX3" y="csY3"/>
+              </a:cxn>
+              <a:cxn ang="0">
+                <a:pos x="csX4" y="csY4"/>
+              </a:cxn>
+            </a:cxnLst>
+            <a:rect l="l" t="t" r="r" b="b"/>
+            <a:pathLst>
+              <a:path w="3321934" h="3321934" extrusionOk="0">
+                <a:moveTo>
+                  <a:pt x="0" y="1660967"/>
+                </a:moveTo>
+                <a:cubicBezTo>
+                  <a:pt x="-167409" y="803095"/>
+                  <a:pt x="949676" y="-96355"/>
+                  <a:pt x="1660967" y="0"/>
+                </a:cubicBezTo>
+                <a:cubicBezTo>
+                  <a:pt x="2550306" y="-18993"/>
+                  <a:pt x="3525890" y="728169"/>
+                  <a:pt x="3321934" y="1660967"/>
+                </a:cubicBezTo>
+                <a:cubicBezTo>
+                  <a:pt x="3382536" y="2527150"/>
+                  <a:pt x="2543303" y="3312466"/>
+                  <a:pt x="1660967" y="3321934"/>
+                </a:cubicBezTo>
+                <a:cubicBezTo>
+                  <a:pt x="921803" y="3319541"/>
+                  <a:pt x="3369" y="2534635"/>
+                  <a:pt x="0" y="1660967"/>
+                </a:cubicBezTo>
+                <a:close/>
+              </a:path>
+            </a:pathLst>
+          </a:custGeom>
+          <a:noFill/>
+          <a:ln w="38100">
+            <a:solidFill>
+              <a:schemeClr val="tx1"/>
+            </a:solidFill>
+            <a:extLst>
+              <a:ext uri="{C807C97D-BFC1-408E-A445-0C87EB9F89A2}">
+                <ask:lineSketchStyleProps xmlns:ask="http://schemas.microsoft.com/office/drawing/2018/sketchyshapes" sd="1207386977">
+                  <a:prstGeom prst="ellipse">
+                    <a:avLst/>
+                  </a:prstGeom>
+                  <ask:type>
+                    <ask:lineSketchFreehand/>
+                  </ask:type>
+                </ask:lineSketchStyleProps>
+              </a:ext>
+            </a:extLst>
+          </a:ln>
+        </p:spPr>
+        <p:style>
+          <a:lnRef idx="2">
+            <a:schemeClr val="accent1">
+              <a:shade val="15000"/>
+            </a:schemeClr>
+          </a:lnRef>
+          <a:fillRef idx="1">
+            <a:schemeClr val="accent1"/>
+          </a:fillRef>
+          <a:effectRef idx="0">
+            <a:schemeClr val="accent1"/>
+          </a:effectRef>
+          <a:fontRef idx="minor">
+            <a:schemeClr val="lt1"/>
+          </a:fontRef>
+        </p:style>
+        <p:txBody>
+          <a:bodyPr rtlCol="0" anchor="ctr"/>
+          <a:lstStyle/>
+          <a:p>
+            <a:pPr algn="ctr"/>
+            <a:endParaRPr lang="en-US"/>
+          </a:p>
+        </p:txBody>
+      </p:sp>
+      <p:sp>
+        <p:nvSpPr>
+          <p:cNvPr id="21" name="Овал 20">
+            <a:extLst>
+              <a:ext uri="{FF2B5EF4-FFF2-40B4-BE49-F238E27FC236}">
+                <a16:creationId xmlns:a16="http://schemas.microsoft.com/office/drawing/2014/main" id="{8E026563-CC01-5200-C36A-8B07E1BF0EF5}"/>
+              </a:ext>
+            </a:extLst>
+          </p:cNvPr>
+          <p:cNvSpPr/>
+          <p:nvPr/>
+        </p:nvSpPr>
+        <p:spPr>
+          <a:xfrm rot="2891641">
+            <a:off x="6780346" y="1386065"/>
+            <a:ext cx="3321934" cy="3321934"/>
+          </a:xfrm>
+          <a:custGeom>
+            <a:avLst/>
+            <a:gdLst>
+              <a:gd name="csX0" fmla="*/ 0 w 3321934"/>
+              <a:gd name="csY0" fmla="*/ 1660967 h 3321934"/>
+              <a:gd name="csX1" fmla="*/ 1660967 w 3321934"/>
+              <a:gd name="csY1" fmla="*/ 0 h 3321934"/>
+              <a:gd name="csX2" fmla="*/ 3321934 w 3321934"/>
+              <a:gd name="csY2" fmla="*/ 1660967 h 3321934"/>
+              <a:gd name="csX3" fmla="*/ 1660967 w 3321934"/>
+              <a:gd name="csY3" fmla="*/ 3321934 h 3321934"/>
+              <a:gd name="csX4" fmla="*/ 0 w 3321934"/>
+              <a:gd name="csY4" fmla="*/ 1660967 h 3321934"/>
+            </a:gdLst>
+            <a:ahLst/>
+            <a:cxnLst>
+              <a:cxn ang="0">
+                <a:pos x="csX0" y="csY0"/>
+              </a:cxn>
+              <a:cxn ang="0">
+                <a:pos x="csX1" y="csY1"/>
+              </a:cxn>
+              <a:cxn ang="0">
+                <a:pos x="csX2" y="csY2"/>
+              </a:cxn>
+              <a:cxn ang="0">
+                <a:pos x="csX3" y="csY3"/>
+              </a:cxn>
+              <a:cxn ang="0">
+                <a:pos x="csX4" y="csY4"/>
+              </a:cxn>
+            </a:cxnLst>
+            <a:rect l="l" t="t" r="r" b="b"/>
+            <a:pathLst>
+              <a:path w="3321934" h="3321934" extrusionOk="0">
+                <a:moveTo>
+                  <a:pt x="0" y="1660967"/>
+                </a:moveTo>
+                <a:cubicBezTo>
+                  <a:pt x="-167409" y="803095"/>
+                  <a:pt x="949676" y="-96355"/>
+                  <a:pt x="1660967" y="0"/>
+                </a:cubicBezTo>
+                <a:cubicBezTo>
+                  <a:pt x="2550306" y="-18993"/>
+                  <a:pt x="3525890" y="728169"/>
+                  <a:pt x="3321934" y="1660967"/>
+                </a:cubicBezTo>
+                <a:cubicBezTo>
+                  <a:pt x="3382536" y="2527150"/>
+                  <a:pt x="2543303" y="3312466"/>
+                  <a:pt x="1660967" y="3321934"/>
+                </a:cubicBezTo>
+                <a:cubicBezTo>
+                  <a:pt x="921803" y="3319541"/>
+                  <a:pt x="3369" y="2534635"/>
+                  <a:pt x="0" y="1660967"/>
+                </a:cubicBezTo>
+                <a:close/>
+              </a:path>
+            </a:pathLst>
+          </a:custGeom>
+          <a:noFill/>
+          <a:ln w="38100">
+            <a:solidFill>
+              <a:schemeClr val="tx1"/>
+            </a:solidFill>
+            <a:extLst>
+              <a:ext uri="{C807C97D-BFC1-408E-A445-0C87EB9F89A2}">
+                <ask:lineSketchStyleProps xmlns:ask="http://schemas.microsoft.com/office/drawing/2018/sketchyshapes" sd="1207386977">
+                  <a:prstGeom prst="ellipse">
+                    <a:avLst/>
+                  </a:prstGeom>
+                  <ask:type>
+                    <ask:lineSketchFreehand/>
+                  </ask:type>
+                </ask:lineSketchStyleProps>
+              </a:ext>
+            </a:extLst>
+          </a:ln>
+        </p:spPr>
+        <p:style>
+          <a:lnRef idx="2">
+            <a:schemeClr val="accent1">
+              <a:shade val="15000"/>
+            </a:schemeClr>
+          </a:lnRef>
+          <a:fillRef idx="1">
+            <a:schemeClr val="accent1"/>
+          </a:fillRef>
+          <a:effectRef idx="0">
+            <a:schemeClr val="accent1"/>
+          </a:effectRef>
+          <a:fontRef idx="minor">
+            <a:schemeClr val="lt1"/>
+          </a:fontRef>
+        </p:style>
+        <p:txBody>
+          <a:bodyPr rtlCol="0" anchor="ctr"/>
+          <a:lstStyle/>
+          <a:p>
+            <a:pPr algn="ctr"/>
+            <a:endParaRPr lang="en-US"/>
+          </a:p>
+        </p:txBody>
+      </p:sp>
+      <p:sp>
+        <p:nvSpPr>
+          <p:cNvPr id="25" name="TextBox 24">
+            <a:extLst>
+              <a:ext uri="{FF2B5EF4-FFF2-40B4-BE49-F238E27FC236}">
+                <a16:creationId xmlns:a16="http://schemas.microsoft.com/office/drawing/2014/main" id="{A30F3D50-C6E3-9CDB-92A9-B49C94E2DBA5}"/>
+              </a:ext>
+            </a:extLst>
+          </p:cNvPr>
+          <p:cNvSpPr txBox="1"/>
+          <p:nvPr/>
+        </p:nvSpPr>
+        <p:spPr>
+          <a:xfrm>
+            <a:off x="2241633" y="5294859"/>
+            <a:ext cx="2424053" cy="369332"/>
+          </a:xfrm>
+          <a:prstGeom prst="rect">
+            <a:avLst/>
+          </a:prstGeom>
+          <a:noFill/>
+        </p:spPr>
+        <p:txBody>
+          <a:bodyPr wrap="square">
+            <a:spAutoFit/>
+          </a:bodyPr>
+          <a:lstStyle/>
+          <a:p>
+            <a:r>
+              <a:rPr lang="en-US" dirty="0">
+                <a:latin typeface="GOST type A" panose="020B0500000000000000" pitchFamily="34" charset="0"/>
+              </a:rPr>
+              <a:t>https://github.com/eshsen</a:t>
+            </a:r>
+          </a:p>
+        </p:txBody>
+      </p:sp>
+      <p:sp>
+        <p:nvSpPr>
+          <p:cNvPr id="27" name="TextBox 26">
+            <a:extLst>
+              <a:ext uri="{FF2B5EF4-FFF2-40B4-BE49-F238E27FC236}">
+                <a16:creationId xmlns:a16="http://schemas.microsoft.com/office/drawing/2014/main" id="{944EF86E-29BB-0A42-8039-7E6151AC4753}"/>
+              </a:ext>
+            </a:extLst>
+          </p:cNvPr>
+          <p:cNvSpPr txBox="1"/>
+          <p:nvPr/>
+        </p:nvSpPr>
+        <p:spPr>
+          <a:xfrm>
+            <a:off x="7343295" y="5326567"/>
+            <a:ext cx="3047035" cy="369332"/>
+          </a:xfrm>
+          <a:prstGeom prst="rect">
+            <a:avLst/>
+          </a:prstGeom>
+          <a:noFill/>
+        </p:spPr>
+        <p:txBody>
+          <a:bodyPr wrap="square">
+            <a:spAutoFit/>
+          </a:bodyPr>
+          <a:lstStyle/>
+          <a:p>
+            <a:r>
+              <a:rPr lang="en-US" dirty="0">
+                <a:latin typeface="GOST type A" panose="020B0500000000000000" pitchFamily="34" charset="0"/>
+              </a:rPr>
+              <a:t>https://github.com/SollyMor</a:t>
+            </a:r>
+          </a:p>
+        </p:txBody>
+      </p:sp>
+    </p:spTree>
+    <p:extLst>
+      <p:ext uri="{BB962C8B-B14F-4D97-AF65-F5344CB8AC3E}">
+        <p14:creationId xmlns:p14="http://schemas.microsoft.com/office/powerpoint/2010/main" val="2811943427"/>
       </p:ext>
     </p:extLst>
   </p:cSld>
@@ -5396,7 +6228,7 @@
         </p:nvSpPr>
         <p:spPr>
           <a:xfrm>
-            <a:off x="1137920" y="1152433"/>
+            <a:off x="1204989" y="1230525"/>
             <a:ext cx="4673600" cy="1889760"/>
           </a:xfrm>
           <a:custGeom>
@@ -9626,6 +10458,348 @@
 </file>
 
 <file path=ppt/slides/slide4.xml><?xml version="1.0" encoding="utf-8"?>
+<p:sld xmlns:a="http://schemas.openxmlformats.org/drawingml/2006/main" xmlns:r="http://schemas.openxmlformats.org/officeDocument/2006/relationships" xmlns:p="http://schemas.openxmlformats.org/presentationml/2006/main">
+  <p:cSld>
+    <p:spTree>
+      <p:nvGrpSpPr>
+        <p:cNvPr id="1" name="">
+          <a:extLst>
+            <a:ext uri="{FF2B5EF4-FFF2-40B4-BE49-F238E27FC236}">
+              <a16:creationId xmlns:a16="http://schemas.microsoft.com/office/drawing/2014/main" id="{46680F05-A133-2EBF-36F3-DD417E6ADB80}"/>
+            </a:ext>
+          </a:extLst>
+        </p:cNvPr>
+        <p:cNvGrpSpPr/>
+        <p:nvPr/>
+      </p:nvGrpSpPr>
+      <p:grpSpPr>
+        <a:xfrm>
+          <a:off x="0" y="0"/>
+          <a:ext cx="0" cy="0"/>
+          <a:chOff x="0" y="0"/>
+          <a:chExt cx="0" cy="0"/>
+        </a:xfrm>
+      </p:grpSpPr>
+      <p:pic>
+        <p:nvPicPr>
+          <p:cNvPr id="2050" name="Picture 2" descr="Picture background">
+            <a:extLst>
+              <a:ext uri="{FF2B5EF4-FFF2-40B4-BE49-F238E27FC236}">
+                <a16:creationId xmlns:a16="http://schemas.microsoft.com/office/drawing/2014/main" id="{866FCD80-092F-AD35-1A0F-02700E42495B}"/>
+              </a:ext>
+            </a:extLst>
+          </p:cNvPr>
+          <p:cNvPicPr>
+            <a:picLocks noChangeAspect="1" noChangeArrowheads="1"/>
+          </p:cNvPicPr>
+          <p:nvPr/>
+        </p:nvPicPr>
+        <p:blipFill>
+          <a:blip r:embed="rId2">
+            <a:alphaModFix amt="53000"/>
+            <a:extLst>
+              <a:ext uri="{BEBA8EAE-BF5A-486C-A8C5-ECC9F3942E4B}">
+                <a14:imgProps xmlns:a14="http://schemas.microsoft.com/office/drawing/2010/main">
+                  <a14:imgLayer r:embed="rId3">
+                    <a14:imgEffect>
+                      <a14:saturation sat="99000"/>
+                    </a14:imgEffect>
+                  </a14:imgLayer>
+                </a14:imgProps>
+              </a:ext>
+              <a:ext uri="{28A0092B-C50C-407E-A947-70E740481C1C}">
+                <a14:useLocalDpi xmlns:a14="http://schemas.microsoft.com/office/drawing/2010/main" val="0"/>
+              </a:ext>
+            </a:extLst>
+          </a:blip>
+          <a:srcRect/>
+          <a:stretch>
+            <a:fillRect/>
+          </a:stretch>
+        </p:blipFill>
+        <p:spPr bwMode="auto">
+          <a:xfrm rot="2240198">
+            <a:off x="9114482" y="208540"/>
+            <a:ext cx="4787096" cy="4787096"/>
+          </a:xfrm>
+          <a:prstGeom prst="rect">
+            <a:avLst/>
+          </a:prstGeom>
+          <a:noFill/>
+          <a:effectLst>
+            <a:glow>
+              <a:schemeClr val="accent1"/>
+            </a:glow>
+            <a:reflection blurRad="63500" stA="45000" endPos="65000" dist="50800" dir="5400000" sy="-100000" algn="bl" rotWithShape="0"/>
+            <a:softEdge rad="711200"/>
+          </a:effectLst>
+          <a:extLst>
+            <a:ext uri="{909E8E84-426E-40DD-AFC4-6F175D3DCCD1}">
+              <a14:hiddenFill xmlns:a14="http://schemas.microsoft.com/office/drawing/2010/main">
+                <a:solidFill>
+                  <a:srgbClr val="FFFFFF"/>
+                </a:solidFill>
+              </a14:hiddenFill>
+            </a:ext>
+          </a:extLst>
+        </p:spPr>
+      </p:pic>
+      <p:sp>
+        <p:nvSpPr>
+          <p:cNvPr id="3" name="TextBox 2">
+            <a:extLst>
+              <a:ext uri="{FF2B5EF4-FFF2-40B4-BE49-F238E27FC236}">
+                <a16:creationId xmlns:a16="http://schemas.microsoft.com/office/drawing/2014/main" id="{CAA9238A-6B24-5425-E0BE-E0A5DDF36816}"/>
+              </a:ext>
+            </a:extLst>
+          </p:cNvPr>
+          <p:cNvSpPr txBox="1"/>
+          <p:nvPr/>
+        </p:nvSpPr>
+        <p:spPr>
+          <a:xfrm>
+            <a:off x="2578227" y="2172228"/>
+            <a:ext cx="2921000" cy="646331"/>
+          </a:xfrm>
+          <a:prstGeom prst="rect">
+            <a:avLst/>
+          </a:prstGeom>
+          <a:noFill/>
+        </p:spPr>
+        <p:txBody>
+          <a:bodyPr wrap="square">
+            <a:spAutoFit/>
+          </a:bodyPr>
+          <a:lstStyle/>
+          <a:p>
+            <a:pPr algn="ctr"/>
+            <a:r>
+              <a:rPr lang="ru-RU" sz="3600" b="1" dirty="0">
+                <a:latin typeface="GOST type A" panose="020B0500000000000000" pitchFamily="34" charset="0"/>
+              </a:rPr>
+              <a:t>Рынок</a:t>
+            </a:r>
+            <a:endParaRPr lang="en-US" sz="3600" b="1" dirty="0">
+              <a:latin typeface="GOST type A" panose="020B0500000000000000" pitchFamily="34" charset="0"/>
+            </a:endParaRPr>
+          </a:p>
+        </p:txBody>
+      </p:sp>
+      <p:sp>
+        <p:nvSpPr>
+          <p:cNvPr id="5" name="TextBox 4">
+            <a:extLst>
+              <a:ext uri="{FF2B5EF4-FFF2-40B4-BE49-F238E27FC236}">
+                <a16:creationId xmlns:a16="http://schemas.microsoft.com/office/drawing/2014/main" id="{1A2A36A3-E505-4663-C08E-B37DC860601D}"/>
+              </a:ext>
+            </a:extLst>
+          </p:cNvPr>
+          <p:cNvSpPr txBox="1"/>
+          <p:nvPr/>
+        </p:nvSpPr>
+        <p:spPr>
+          <a:xfrm>
+            <a:off x="1147039" y="3238547"/>
+            <a:ext cx="8463280" cy="1815882"/>
+          </a:xfrm>
+          <a:prstGeom prst="rect">
+            <a:avLst/>
+          </a:prstGeom>
+          <a:noFill/>
+        </p:spPr>
+        <p:txBody>
+          <a:bodyPr wrap="square">
+            <a:spAutoFit/>
+          </a:bodyPr>
+          <a:lstStyle/>
+          <a:p>
+            <a:pPr marL="285750" indent="-285750">
+              <a:buFont typeface="Arial" panose="020B0604020202020204" pitchFamily="34" charset="0"/>
+              <a:buChar char="•"/>
+            </a:pPr>
+            <a:r>
+              <a:rPr lang="ru-RU" sz="2800" dirty="0">
+                <a:latin typeface="GOST type A" panose="020B0500000000000000" pitchFamily="34" charset="0"/>
+              </a:rPr>
+              <a:t>Рынок изучения китайского языка - </a:t>
+            </a:r>
+            <a:r>
+              <a:rPr lang="en-US" sz="2800" dirty="0">
+                <a:latin typeface="GOST type A" panose="020B0500000000000000" pitchFamily="34" charset="0"/>
+              </a:rPr>
+              <a:t>$</a:t>
+            </a:r>
+            <a:r>
+              <a:rPr lang="ru-RU" sz="2800" dirty="0">
+                <a:latin typeface="GOST type A" panose="020B0500000000000000" pitchFamily="34" charset="0"/>
+              </a:rPr>
+              <a:t>7.4 млрд</a:t>
+            </a:r>
+          </a:p>
+          <a:p>
+            <a:pPr marL="285750" indent="-285750">
+              <a:buFont typeface="Arial" panose="020B0604020202020204" pitchFamily="34" charset="0"/>
+              <a:buChar char="•"/>
+            </a:pPr>
+            <a:r>
+              <a:rPr lang="ru-RU" sz="2800" dirty="0">
+                <a:latin typeface="GOST type A" panose="020B0500000000000000" pitchFamily="34" charset="0"/>
+              </a:rPr>
+              <a:t>Рост до </a:t>
+            </a:r>
+            <a:r>
+              <a:rPr lang="en-US" sz="2800" dirty="0">
+                <a:latin typeface="GOST type A" panose="020B0500000000000000" pitchFamily="34" charset="0"/>
+              </a:rPr>
+              <a:t>$</a:t>
+            </a:r>
+            <a:r>
+              <a:rPr lang="ru-RU" sz="2800" dirty="0">
+                <a:latin typeface="GOST type A" panose="020B0500000000000000" pitchFamily="34" charset="0"/>
+              </a:rPr>
+              <a:t>13.1 млрд к 2027</a:t>
+            </a:r>
+          </a:p>
+          <a:p>
+            <a:pPr marL="285750" indent="-285750">
+              <a:buFont typeface="Arial" panose="020B0604020202020204" pitchFamily="34" charset="0"/>
+              <a:buChar char="•"/>
+            </a:pPr>
+            <a:r>
+              <a:rPr lang="en-US" sz="2800" dirty="0">
+                <a:latin typeface="GOST type A" panose="020B0500000000000000" pitchFamily="34" charset="0"/>
+              </a:rPr>
+              <a:t>CAGR – 12.1%</a:t>
+            </a:r>
+            <a:endParaRPr lang="ru-RU" sz="2800" dirty="0">
+              <a:latin typeface="GOST type A" panose="020B0500000000000000" pitchFamily="34" charset="0"/>
+            </a:endParaRPr>
+          </a:p>
+          <a:p>
+            <a:pPr marL="285750" indent="-285750">
+              <a:buFont typeface="Arial" panose="020B0604020202020204" pitchFamily="34" charset="0"/>
+              <a:buChar char="•"/>
+            </a:pPr>
+            <a:r>
+              <a:rPr lang="en-US" sz="2800" dirty="0">
+                <a:latin typeface="GOST type A" panose="020B0500000000000000" pitchFamily="34" charset="0"/>
+              </a:rPr>
+              <a:t>6+</a:t>
+            </a:r>
+            <a:r>
+              <a:rPr lang="ru-RU" sz="2800" dirty="0">
+                <a:latin typeface="GOST type A" panose="020B0500000000000000" pitchFamily="34" charset="0"/>
+              </a:rPr>
+              <a:t> млн</a:t>
+            </a:r>
+            <a:r>
+              <a:rPr lang="en-US" sz="2800" dirty="0">
+                <a:latin typeface="GOST type A" panose="020B0500000000000000" pitchFamily="34" charset="0"/>
+              </a:rPr>
+              <a:t> </a:t>
+            </a:r>
+            <a:r>
+              <a:rPr lang="ru-RU" sz="2800" dirty="0">
+                <a:latin typeface="GOST type A" panose="020B0500000000000000" pitchFamily="34" charset="0"/>
+              </a:rPr>
+              <a:t>учащихся по всему миру</a:t>
+            </a:r>
+            <a:endParaRPr lang="en-US" sz="2800" dirty="0">
+              <a:latin typeface="GOST type A" panose="020B0500000000000000" pitchFamily="34" charset="0"/>
+            </a:endParaRPr>
+          </a:p>
+        </p:txBody>
+      </p:sp>
+      <p:cxnSp>
+        <p:nvCxnSpPr>
+          <p:cNvPr id="9" name="Прямая соединительная линия 8">
+            <a:extLst>
+              <a:ext uri="{FF2B5EF4-FFF2-40B4-BE49-F238E27FC236}">
+                <a16:creationId xmlns:a16="http://schemas.microsoft.com/office/drawing/2014/main" id="{B678A16D-824C-DD60-74DD-82EAE95C69DB}"/>
+              </a:ext>
+            </a:extLst>
+          </p:cNvPr>
+          <p:cNvCxnSpPr>
+            <a:cxnSpLocks/>
+          </p:cNvCxnSpPr>
+          <p:nvPr/>
+        </p:nvCxnSpPr>
+        <p:spPr>
+          <a:xfrm>
+            <a:off x="1043260" y="3044900"/>
+            <a:ext cx="6736466" cy="0"/>
+          </a:xfrm>
+          <a:prstGeom prst="line">
+            <a:avLst/>
+          </a:prstGeom>
+        </p:spPr>
+        <p:style>
+          <a:lnRef idx="2">
+            <a:schemeClr val="dk1"/>
+          </a:lnRef>
+          <a:fillRef idx="0">
+            <a:schemeClr val="dk1"/>
+          </a:fillRef>
+          <a:effectRef idx="1">
+            <a:schemeClr val="dk1"/>
+          </a:effectRef>
+          <a:fontRef idx="minor">
+            <a:schemeClr val="tx1"/>
+          </a:fontRef>
+        </p:style>
+      </p:cxnSp>
+      <p:cxnSp>
+        <p:nvCxnSpPr>
+          <p:cNvPr id="10" name="Прямая соединительная линия 9">
+            <a:extLst>
+              <a:ext uri="{FF2B5EF4-FFF2-40B4-BE49-F238E27FC236}">
+                <a16:creationId xmlns:a16="http://schemas.microsoft.com/office/drawing/2014/main" id="{244AA318-3669-5F5A-EB5D-736AAA41C824}"/>
+              </a:ext>
+            </a:extLst>
+          </p:cNvPr>
+          <p:cNvCxnSpPr>
+            <a:cxnSpLocks/>
+          </p:cNvCxnSpPr>
+          <p:nvPr/>
+        </p:nvCxnSpPr>
+        <p:spPr>
+          <a:xfrm>
+            <a:off x="1147039" y="5298669"/>
+            <a:ext cx="6736466" cy="0"/>
+          </a:xfrm>
+          <a:prstGeom prst="line">
+            <a:avLst/>
+          </a:prstGeom>
+        </p:spPr>
+        <p:style>
+          <a:lnRef idx="2">
+            <a:schemeClr val="dk1"/>
+          </a:lnRef>
+          <a:fillRef idx="0">
+            <a:schemeClr val="dk1"/>
+          </a:fillRef>
+          <a:effectRef idx="1">
+            <a:schemeClr val="dk1"/>
+          </a:effectRef>
+          <a:fontRef idx="minor">
+            <a:schemeClr val="tx1"/>
+          </a:fontRef>
+        </p:style>
+      </p:cxnSp>
+    </p:spTree>
+    <p:extLst>
+      <p:ext uri="{BB962C8B-B14F-4D97-AF65-F5344CB8AC3E}">
+        <p14:creationId xmlns:p14="http://schemas.microsoft.com/office/powerpoint/2010/main" val="3523755613"/>
+      </p:ext>
+    </p:extLst>
+  </p:cSld>
+  <p:clrMapOvr>
+    <a:masterClrMapping/>
+  </p:clrMapOvr>
+</p:sld>
+</file>
+
+<file path=ppt/slides/slide5.xml><?xml version="1.0" encoding="utf-8"?>
 <p:sld xmlns:a="http://schemas.openxmlformats.org/drawingml/2006/main" xmlns:r="http://schemas.openxmlformats.org/officeDocument/2006/relationships" xmlns:p="http://schemas.openxmlformats.org/presentationml/2006/main">
   <p:cSld>
     <p:spTree>
@@ -11651,7 +12825,7 @@
 </p:sld>
 </file>
 
-<file path=ppt/slides/slide5.xml><?xml version="1.0" encoding="utf-8"?>
+<file path=ppt/slides/slide6.xml><?xml version="1.0" encoding="utf-8"?>
 <p:sld xmlns:a="http://schemas.openxmlformats.org/drawingml/2006/main" xmlns:r="http://schemas.openxmlformats.org/officeDocument/2006/relationships" xmlns:p="http://schemas.openxmlformats.org/presentationml/2006/main">
   <p:cSld>
     <p:spTree>
@@ -11947,7 +13121,811 @@
 </p:sld>
 </file>
 
-<file path=ppt/slides/slide6.xml><?xml version="1.0" encoding="utf-8"?>
+<file path=ppt/slides/slide7.xml><?xml version="1.0" encoding="utf-8"?>
+<p:sld xmlns:a="http://schemas.openxmlformats.org/drawingml/2006/main" xmlns:r="http://schemas.openxmlformats.org/officeDocument/2006/relationships" xmlns:p="http://schemas.openxmlformats.org/presentationml/2006/main">
+  <p:cSld>
+    <p:spTree>
+      <p:nvGrpSpPr>
+        <p:cNvPr id="1" name=""/>
+        <p:cNvGrpSpPr/>
+        <p:nvPr/>
+      </p:nvGrpSpPr>
+      <p:grpSpPr>
+        <a:xfrm>
+          <a:off x="0" y="0"/>
+          <a:ext cx="0" cy="0"/>
+          <a:chOff x="0" y="0"/>
+          <a:chExt cx="0" cy="0"/>
+        </a:xfrm>
+      </p:grpSpPr>
+      <p:pic>
+        <p:nvPicPr>
+          <p:cNvPr id="6" name="Рисунок 5">
+            <a:extLst>
+              <a:ext uri="{FF2B5EF4-FFF2-40B4-BE49-F238E27FC236}">
+                <a16:creationId xmlns:a16="http://schemas.microsoft.com/office/drawing/2014/main" id="{273C64F6-C198-0289-FB39-5F00E0648003}"/>
+              </a:ext>
+            </a:extLst>
+          </p:cNvPr>
+          <p:cNvPicPr>
+            <a:picLocks noChangeAspect="1"/>
+          </p:cNvPicPr>
+          <p:nvPr/>
+        </p:nvPicPr>
+        <p:blipFill>
+          <a:blip r:embed="rId2">
+            <a:alphaModFix/>
+            <a:extLst>
+              <a:ext uri="{BEBA8EAE-BF5A-486C-A8C5-ECC9F3942E4B}">
+                <a14:imgProps xmlns:a14="http://schemas.microsoft.com/office/drawing/2010/main">
+                  <a14:imgLayer r:embed="rId3">
+                    <a14:imgEffect>
+                      <a14:sharpenSoften amount="-61000"/>
+                    </a14:imgEffect>
+                    <a14:imgEffect>
+                      <a14:saturation sat="63000"/>
+                    </a14:imgEffect>
+                  </a14:imgLayer>
+                </a14:imgProps>
+              </a:ext>
+              <a:ext uri="{28A0092B-C50C-407E-A947-70E740481C1C}">
+                <a14:useLocalDpi xmlns:a14="http://schemas.microsoft.com/office/drawing/2010/main" val="0"/>
+              </a:ext>
+            </a:extLst>
+          </a:blip>
+          <a:stretch>
+            <a:fillRect/>
+          </a:stretch>
+        </p:blipFill>
+        <p:spPr>
+          <a:xfrm>
+            <a:off x="0" y="78739"/>
+            <a:ext cx="12270658" cy="7344616"/>
+          </a:xfrm>
+          <a:prstGeom prst="rect">
+            <a:avLst/>
+          </a:prstGeom>
+        </p:spPr>
+      </p:pic>
+      <p:sp>
+        <p:nvSpPr>
+          <p:cNvPr id="3" name="TextBox 2">
+            <a:extLst>
+              <a:ext uri="{FF2B5EF4-FFF2-40B4-BE49-F238E27FC236}">
+                <a16:creationId xmlns:a16="http://schemas.microsoft.com/office/drawing/2014/main" id="{11F8B7F2-5828-7CE9-9CF3-CF51285E6927}"/>
+              </a:ext>
+            </a:extLst>
+          </p:cNvPr>
+          <p:cNvSpPr txBox="1"/>
+          <p:nvPr/>
+        </p:nvSpPr>
+        <p:spPr>
+          <a:xfrm>
+            <a:off x="5043947" y="326924"/>
+            <a:ext cx="2104103" cy="646331"/>
+          </a:xfrm>
+          <a:prstGeom prst="rect">
+            <a:avLst/>
+          </a:prstGeom>
+          <a:noFill/>
+        </p:spPr>
+        <p:txBody>
+          <a:bodyPr wrap="square">
+            <a:spAutoFit/>
+          </a:bodyPr>
+          <a:lstStyle/>
+          <a:p>
+            <a:r>
+              <a:rPr lang="ru-RU" sz="3600" b="1" dirty="0">
+                <a:latin typeface="GOST type A" panose="020B0500000000000000" pitchFamily="34" charset="0"/>
+              </a:rPr>
+              <a:t>Технологии</a:t>
+            </a:r>
+            <a:endParaRPr lang="en-US" sz="3600" b="1" dirty="0">
+              <a:latin typeface="GOST type A" panose="020B0500000000000000" pitchFamily="34" charset="0"/>
+            </a:endParaRPr>
+          </a:p>
+        </p:txBody>
+      </p:sp>
+      <p:graphicFrame>
+        <p:nvGraphicFramePr>
+          <p:cNvPr id="4" name="Таблица 3">
+            <a:extLst>
+              <a:ext uri="{FF2B5EF4-FFF2-40B4-BE49-F238E27FC236}">
+                <a16:creationId xmlns:a16="http://schemas.microsoft.com/office/drawing/2014/main" id="{88E4D4F0-0D92-BFEF-417D-D421B8467D51}"/>
+              </a:ext>
+            </a:extLst>
+          </p:cNvPr>
+          <p:cNvGraphicFramePr>
+            <a:graphicFrameLocks noGrp="1"/>
+          </p:cNvGraphicFramePr>
+          <p:nvPr>
+            <p:extLst>
+              <p:ext uri="{D42A27DB-BD31-4B8C-83A1-F6EECF244321}">
+                <p14:modId xmlns:p14="http://schemas.microsoft.com/office/powerpoint/2010/main" val="836658227"/>
+              </p:ext>
+            </p:extLst>
+          </p:nvPr>
+        </p:nvGraphicFramePr>
+        <p:xfrm>
+          <a:off x="891047" y="1221440"/>
+          <a:ext cx="10409904" cy="4293199"/>
+        </p:xfrm>
+        <a:graphic>
+          <a:graphicData uri="http://schemas.openxmlformats.org/drawingml/2006/table">
+            <a:tbl>
+              <a:tblPr>
+                <a:tableStyleId>{2D5ABB26-0587-4C30-8999-92F81FD0307C}</a:tableStyleId>
+              </a:tblPr>
+              <a:tblGrid>
+                <a:gridCol w="3237053">
+                  <a:extLst>
+                    <a:ext uri="{9D8B030D-6E8A-4147-A177-3AD203B41FA5}">
+                      <a16:colId xmlns:a16="http://schemas.microsoft.com/office/drawing/2014/main" val="1230056442"/>
+                    </a:ext>
+                  </a:extLst>
+                </a:gridCol>
+                <a:gridCol w="7172851">
+                  <a:extLst>
+                    <a:ext uri="{9D8B030D-6E8A-4147-A177-3AD203B41FA5}">
+                      <a16:colId xmlns:a16="http://schemas.microsoft.com/office/drawing/2014/main" val="1817303759"/>
+                    </a:ext>
+                  </a:extLst>
+                </a:gridCol>
+              </a:tblGrid>
+              <a:tr h="0">
+                <a:tc>
+                  <a:txBody>
+                    <a:bodyPr/>
+                    <a:lstStyle/>
+                    <a:p>
+                      <a:pPr>
+                        <a:buNone/>
+                      </a:pPr>
+                      <a:r>
+                        <a:rPr lang="ru-RU" sz="2400" b="1" dirty="0">
+                          <a:latin typeface="GOST type A" panose="020B0500000000000000" pitchFamily="34" charset="0"/>
+                        </a:rPr>
+                        <a:t>Технология</a:t>
+                      </a:r>
+                    </a:p>
+                  </a:txBody>
+                  <a:tcPr anchor="ctr">
+                    <a:lnL w="12700" cap="flat" cmpd="sng" algn="ctr">
+                      <a:noFill/>
+                      <a:prstDash val="solid"/>
+                      <a:round/>
+                      <a:headEnd type="none" w="med" len="med"/>
+                      <a:tailEnd type="none" w="med" len="med"/>
+                    </a:lnL>
+                    <a:lnR w="12700" cap="flat" cmpd="sng" algn="ctr">
+                      <a:noFill/>
+                      <a:prstDash val="solid"/>
+                      <a:round/>
+                      <a:headEnd type="none" w="med" len="med"/>
+                      <a:tailEnd type="none" w="med" len="med"/>
+                    </a:lnR>
+                    <a:lnT w="12700" cap="flat" cmpd="sng" algn="ctr">
+                      <a:noFill/>
+                      <a:prstDash val="solid"/>
+                      <a:round/>
+                      <a:headEnd type="none" w="med" len="med"/>
+                      <a:tailEnd type="none" w="med" len="med"/>
+                    </a:lnT>
+                    <a:lnB w="28575" cap="flat" cmpd="sng" algn="ctr">
+                      <a:solidFill>
+                        <a:schemeClr val="tx1"/>
+                      </a:solidFill>
+                      <a:prstDash val="solid"/>
+                      <a:round/>
+                      <a:headEnd type="none" w="med" len="med"/>
+                      <a:tailEnd type="none" w="med" len="med"/>
+                    </a:lnB>
+                    <a:lnTlToBr w="12700" cmpd="sng">
+                      <a:noFill/>
+                      <a:prstDash val="solid"/>
+                    </a:lnTlToBr>
+                    <a:lnBlToTr w="12700" cmpd="sng">
+                      <a:noFill/>
+                      <a:prstDash val="solid"/>
+                    </a:lnBlToTr>
+                  </a:tcPr>
+                </a:tc>
+                <a:tc>
+                  <a:txBody>
+                    <a:bodyPr/>
+                    <a:lstStyle/>
+                    <a:p>
+                      <a:pPr>
+                        <a:buNone/>
+                      </a:pPr>
+                      <a:r>
+                        <a:rPr lang="ru-RU" sz="2400" b="1" dirty="0">
+                          <a:latin typeface="GOST type A" panose="020B0500000000000000" pitchFamily="34" charset="0"/>
+                        </a:rPr>
+                        <a:t>Что делает в вашем приложении</a:t>
+                      </a:r>
+                    </a:p>
+                  </a:txBody>
+                  <a:tcPr anchor="ctr">
+                    <a:lnL w="12700" cap="flat" cmpd="sng" algn="ctr">
+                      <a:noFill/>
+                      <a:prstDash val="solid"/>
+                      <a:round/>
+                      <a:headEnd type="none" w="med" len="med"/>
+                      <a:tailEnd type="none" w="med" len="med"/>
+                    </a:lnL>
+                    <a:lnB w="28575" cap="flat" cmpd="sng" algn="ctr">
+                      <a:solidFill>
+                        <a:schemeClr val="tx1"/>
+                      </a:solidFill>
+                      <a:prstDash val="solid"/>
+                      <a:round/>
+                      <a:headEnd type="none" w="med" len="med"/>
+                      <a:tailEnd type="none" w="med" len="med"/>
+                    </a:lnB>
+                  </a:tcPr>
+                </a:tc>
+                <a:extLst>
+                  <a:ext uri="{0D108BD9-81ED-4DB2-BD59-A6C34878D82A}">
+                    <a16:rowId xmlns:a16="http://schemas.microsoft.com/office/drawing/2014/main" val="456843220"/>
+                  </a:ext>
+                </a:extLst>
+              </a:tr>
+              <a:tr h="537276">
+                <a:tc>
+                  <a:txBody>
+                    <a:bodyPr/>
+                    <a:lstStyle/>
+                    <a:p>
+                      <a:pPr>
+                        <a:buNone/>
+                      </a:pPr>
+                      <a:endParaRPr lang="ru-RU" sz="2400" b="1" dirty="0">
+                        <a:latin typeface="GOST type A" panose="020B0500000000000000" pitchFamily="34" charset="0"/>
+                      </a:endParaRPr>
+                    </a:p>
+                    <a:p>
+                      <a:pPr>
+                        <a:buNone/>
+                      </a:pPr>
+                      <a:r>
+                        <a:rPr lang="en-US" sz="2400" b="1" dirty="0">
+                          <a:latin typeface="GOST type A" panose="020B0500000000000000" pitchFamily="34" charset="0"/>
+                        </a:rPr>
+                        <a:t>Python</a:t>
+                      </a:r>
+                      <a:endParaRPr lang="en-US" sz="2400" dirty="0">
+                        <a:latin typeface="GOST type A" panose="020B0500000000000000" pitchFamily="34" charset="0"/>
+                      </a:endParaRPr>
+                    </a:p>
+                  </a:txBody>
+                  <a:tcPr anchor="ctr">
+                    <a:lnT w="28575" cap="flat" cmpd="sng" algn="ctr">
+                      <a:solidFill>
+                        <a:schemeClr val="tx1"/>
+                      </a:solidFill>
+                      <a:prstDash val="solid"/>
+                      <a:round/>
+                      <a:headEnd type="none" w="med" len="med"/>
+                      <a:tailEnd type="none" w="med" len="med"/>
+                    </a:lnT>
+                    <a:lnB w="3175" cap="flat" cmpd="sng" algn="ctr">
+                      <a:solidFill>
+                        <a:schemeClr val="tx1"/>
+                      </a:solidFill>
+                      <a:prstDash val="dot"/>
+                      <a:round/>
+                      <a:headEnd type="none" w="med" len="med"/>
+                      <a:tailEnd type="none" w="med" len="med"/>
+                    </a:lnB>
+                  </a:tcPr>
+                </a:tc>
+                <a:tc>
+                  <a:txBody>
+                    <a:bodyPr/>
+                    <a:lstStyle/>
+                    <a:p>
+                      <a:pPr>
+                        <a:buNone/>
+                      </a:pPr>
+                      <a:endParaRPr lang="ru-RU" sz="2000" dirty="0">
+                        <a:latin typeface="GOST type A" panose="020B0500000000000000" pitchFamily="34" charset="0"/>
+                      </a:endParaRPr>
+                    </a:p>
+                    <a:p>
+                      <a:pPr>
+                        <a:buNone/>
+                      </a:pPr>
+                      <a:r>
+                        <a:rPr lang="ru-RU" sz="2000" dirty="0">
+                          <a:latin typeface="GOST type A" panose="020B0500000000000000" pitchFamily="34" charset="0"/>
+                        </a:rPr>
+                        <a:t>Извлекает признаки из изображения иероглифа </a:t>
+                      </a:r>
+                    </a:p>
+                  </a:txBody>
+                  <a:tcPr anchor="ctr">
+                    <a:lnT w="28575" cap="flat" cmpd="sng" algn="ctr">
+                      <a:solidFill>
+                        <a:schemeClr val="tx1"/>
+                      </a:solidFill>
+                      <a:prstDash val="solid"/>
+                      <a:round/>
+                      <a:headEnd type="none" w="med" len="med"/>
+                      <a:tailEnd type="none" w="med" len="med"/>
+                    </a:lnT>
+                    <a:lnB w="3175" cap="flat" cmpd="sng" algn="ctr">
+                      <a:solidFill>
+                        <a:schemeClr val="tx1"/>
+                      </a:solidFill>
+                      <a:prstDash val="dot"/>
+                      <a:round/>
+                      <a:headEnd type="none" w="med" len="med"/>
+                      <a:tailEnd type="none" w="med" len="med"/>
+                    </a:lnB>
+                  </a:tcPr>
+                </a:tc>
+                <a:extLst>
+                  <a:ext uri="{0D108BD9-81ED-4DB2-BD59-A6C34878D82A}">
+                    <a16:rowId xmlns:a16="http://schemas.microsoft.com/office/drawing/2014/main" val="4123265069"/>
+                  </a:ext>
+                </a:extLst>
+              </a:tr>
+              <a:tr h="220791">
+                <a:tc>
+                  <a:txBody>
+                    <a:bodyPr/>
+                    <a:lstStyle/>
+                    <a:p>
+                      <a:pPr>
+                        <a:buNone/>
+                      </a:pPr>
+                      <a:endParaRPr lang="en-US" dirty="0">
+                        <a:latin typeface="GOST type A" panose="020B0500000000000000" pitchFamily="34" charset="0"/>
+                      </a:endParaRPr>
+                    </a:p>
+                  </a:txBody>
+                  <a:tcPr anchor="ctr">
+                    <a:lnT w="3175" cap="flat" cmpd="sng" algn="ctr">
+                      <a:solidFill>
+                        <a:schemeClr val="tx1"/>
+                      </a:solidFill>
+                      <a:prstDash val="dot"/>
+                      <a:round/>
+                      <a:headEnd type="none" w="med" len="med"/>
+                      <a:tailEnd type="none" w="med" len="med"/>
+                    </a:lnT>
+                  </a:tcPr>
+                </a:tc>
+                <a:tc>
+                  <a:txBody>
+                    <a:bodyPr/>
+                    <a:lstStyle/>
+                    <a:p>
+                      <a:pPr>
+                        <a:buNone/>
+                      </a:pPr>
+                      <a:endParaRPr lang="ru-RU" sz="2000" dirty="0">
+                        <a:latin typeface="GOST type A" panose="020B0500000000000000" pitchFamily="34" charset="0"/>
+                      </a:endParaRPr>
+                    </a:p>
+                  </a:txBody>
+                  <a:tcPr anchor="ctr">
+                    <a:lnT w="3175" cap="flat" cmpd="sng" algn="ctr">
+                      <a:solidFill>
+                        <a:schemeClr val="tx1"/>
+                      </a:solidFill>
+                      <a:prstDash val="dot"/>
+                      <a:round/>
+                      <a:headEnd type="none" w="med" len="med"/>
+                      <a:tailEnd type="none" w="med" len="med"/>
+                    </a:lnT>
+                  </a:tcPr>
+                </a:tc>
+                <a:extLst>
+                  <a:ext uri="{0D108BD9-81ED-4DB2-BD59-A6C34878D82A}">
+                    <a16:rowId xmlns:a16="http://schemas.microsoft.com/office/drawing/2014/main" val="3045849024"/>
+                  </a:ext>
+                </a:extLst>
+              </a:tr>
+              <a:tr h="0">
+                <a:tc>
+                  <a:txBody>
+                    <a:bodyPr/>
+                    <a:lstStyle/>
+                    <a:p>
+                      <a:pPr>
+                        <a:buNone/>
+                      </a:pPr>
+                      <a:r>
+                        <a:rPr lang="en-US" sz="2400" b="1" dirty="0">
+                          <a:latin typeface="GOST type A" panose="020B0500000000000000" pitchFamily="34" charset="0"/>
+                        </a:rPr>
+                        <a:t>Node.js</a:t>
+                      </a:r>
+                      <a:endParaRPr lang="en-US" sz="2400" dirty="0">
+                        <a:latin typeface="GOST type A" panose="020B0500000000000000" pitchFamily="34" charset="0"/>
+                      </a:endParaRPr>
+                    </a:p>
+                  </a:txBody>
+                  <a:tcPr anchor="ctr">
+                    <a:lnB w="3175" cap="flat" cmpd="sng" algn="ctr">
+                      <a:solidFill>
+                        <a:schemeClr val="tx1"/>
+                      </a:solidFill>
+                      <a:prstDash val="dot"/>
+                      <a:round/>
+                      <a:headEnd type="none" w="med" len="med"/>
+                      <a:tailEnd type="none" w="med" len="med"/>
+                    </a:lnB>
+                  </a:tcPr>
+                </a:tc>
+                <a:tc>
+                  <a:txBody>
+                    <a:bodyPr/>
+                    <a:lstStyle/>
+                    <a:p>
+                      <a:pPr>
+                        <a:buNone/>
+                      </a:pPr>
+                      <a:r>
+                        <a:rPr lang="ru-RU" sz="2000" dirty="0">
+                          <a:latin typeface="GOST type A" panose="020B0500000000000000" pitchFamily="34" charset="0"/>
+                        </a:rPr>
+                        <a:t>Бэкенд-сервер, обрабатывает запросы от пользователя</a:t>
+                      </a:r>
+                    </a:p>
+                  </a:txBody>
+                  <a:tcPr anchor="ctr">
+                    <a:lnB w="3175" cap="flat" cmpd="sng" algn="ctr">
+                      <a:solidFill>
+                        <a:schemeClr val="tx1"/>
+                      </a:solidFill>
+                      <a:prstDash val="dot"/>
+                      <a:round/>
+                      <a:headEnd type="none" w="med" len="med"/>
+                      <a:tailEnd type="none" w="med" len="med"/>
+                    </a:lnB>
+                  </a:tcPr>
+                </a:tc>
+                <a:extLst>
+                  <a:ext uri="{0D108BD9-81ED-4DB2-BD59-A6C34878D82A}">
+                    <a16:rowId xmlns:a16="http://schemas.microsoft.com/office/drawing/2014/main" val="2816930986"/>
+                  </a:ext>
+                </a:extLst>
+              </a:tr>
+              <a:tr h="135250">
+                <a:tc>
+                  <a:txBody>
+                    <a:bodyPr/>
+                    <a:lstStyle/>
+                    <a:p>
+                      <a:pPr>
+                        <a:buNone/>
+                      </a:pPr>
+                      <a:endParaRPr lang="en-US" dirty="0">
+                        <a:latin typeface="GOST type A" panose="020B0500000000000000" pitchFamily="34" charset="0"/>
+                      </a:endParaRPr>
+                    </a:p>
+                  </a:txBody>
+                  <a:tcPr anchor="ctr">
+                    <a:lnT w="3175" cap="flat" cmpd="sng" algn="ctr">
+                      <a:solidFill>
+                        <a:schemeClr val="tx1"/>
+                      </a:solidFill>
+                      <a:prstDash val="dot"/>
+                      <a:round/>
+                      <a:headEnd type="none" w="med" len="med"/>
+                      <a:tailEnd type="none" w="med" len="med"/>
+                    </a:lnT>
+                  </a:tcPr>
+                </a:tc>
+                <a:tc>
+                  <a:txBody>
+                    <a:bodyPr/>
+                    <a:lstStyle/>
+                    <a:p>
+                      <a:pPr>
+                        <a:buNone/>
+                      </a:pPr>
+                      <a:endParaRPr lang="ru-RU" sz="2000" dirty="0">
+                        <a:latin typeface="GOST type A" panose="020B0500000000000000" pitchFamily="34" charset="0"/>
+                      </a:endParaRPr>
+                    </a:p>
+                  </a:txBody>
+                  <a:tcPr anchor="ctr">
+                    <a:lnT w="3175" cap="flat" cmpd="sng" algn="ctr">
+                      <a:solidFill>
+                        <a:schemeClr val="tx1"/>
+                      </a:solidFill>
+                      <a:prstDash val="dot"/>
+                      <a:round/>
+                      <a:headEnd type="none" w="med" len="med"/>
+                      <a:tailEnd type="none" w="med" len="med"/>
+                    </a:lnT>
+                  </a:tcPr>
+                </a:tc>
+                <a:extLst>
+                  <a:ext uri="{0D108BD9-81ED-4DB2-BD59-A6C34878D82A}">
+                    <a16:rowId xmlns:a16="http://schemas.microsoft.com/office/drawing/2014/main" val="1155286950"/>
+                  </a:ext>
+                </a:extLst>
+              </a:tr>
+              <a:tr h="0">
+                <a:tc>
+                  <a:txBody>
+                    <a:bodyPr/>
+                    <a:lstStyle/>
+                    <a:p>
+                      <a:pPr>
+                        <a:buNone/>
+                      </a:pPr>
+                      <a:r>
+                        <a:rPr lang="en-US" sz="2400" b="1" dirty="0">
+                          <a:latin typeface="GOST type A" panose="020B0500000000000000" pitchFamily="34" charset="0"/>
+                        </a:rPr>
+                        <a:t>SQLite</a:t>
+                      </a:r>
+                      <a:endParaRPr lang="en-US" sz="2400" dirty="0">
+                        <a:latin typeface="GOST type A" panose="020B0500000000000000" pitchFamily="34" charset="0"/>
+                      </a:endParaRPr>
+                    </a:p>
+                  </a:txBody>
+                  <a:tcPr anchor="ctr">
+                    <a:lnB w="3175" cap="flat" cmpd="sng" algn="ctr">
+                      <a:solidFill>
+                        <a:schemeClr val="tx1"/>
+                      </a:solidFill>
+                      <a:prstDash val="dot"/>
+                      <a:round/>
+                      <a:headEnd type="none" w="med" len="med"/>
+                      <a:tailEnd type="none" w="med" len="med"/>
+                    </a:lnB>
+                  </a:tcPr>
+                </a:tc>
+                <a:tc>
+                  <a:txBody>
+                    <a:bodyPr/>
+                    <a:lstStyle/>
+                    <a:p>
+                      <a:pPr>
+                        <a:buNone/>
+                      </a:pPr>
+                      <a:r>
+                        <a:rPr lang="ru-RU" sz="2000" dirty="0">
+                          <a:latin typeface="GOST type A" panose="020B0500000000000000" pitchFamily="34" charset="0"/>
+                        </a:rPr>
+                        <a:t>Хранит 21 056 иероглифов с подробной информацией</a:t>
+                      </a:r>
+                    </a:p>
+                  </a:txBody>
+                  <a:tcPr anchor="ctr">
+                    <a:lnB w="3175" cap="flat" cmpd="sng" algn="ctr">
+                      <a:solidFill>
+                        <a:schemeClr val="tx1"/>
+                      </a:solidFill>
+                      <a:prstDash val="dot"/>
+                      <a:round/>
+                      <a:headEnd type="none" w="med" len="med"/>
+                      <a:tailEnd type="none" w="med" len="med"/>
+                    </a:lnB>
+                  </a:tcPr>
+                </a:tc>
+                <a:extLst>
+                  <a:ext uri="{0D108BD9-81ED-4DB2-BD59-A6C34878D82A}">
+                    <a16:rowId xmlns:a16="http://schemas.microsoft.com/office/drawing/2014/main" val="1098889294"/>
+                  </a:ext>
+                </a:extLst>
+              </a:tr>
+              <a:tr h="320040">
+                <a:tc>
+                  <a:txBody>
+                    <a:bodyPr/>
+                    <a:lstStyle/>
+                    <a:p>
+                      <a:pPr>
+                        <a:buNone/>
+                      </a:pPr>
+                      <a:endParaRPr lang="en-US" dirty="0">
+                        <a:latin typeface="GOST type A" panose="020B0500000000000000" pitchFamily="34" charset="0"/>
+                      </a:endParaRPr>
+                    </a:p>
+                  </a:txBody>
+                  <a:tcPr anchor="ctr">
+                    <a:lnT w="3175" cap="flat" cmpd="sng" algn="ctr">
+                      <a:solidFill>
+                        <a:schemeClr val="tx1"/>
+                      </a:solidFill>
+                      <a:prstDash val="dot"/>
+                      <a:round/>
+                      <a:headEnd type="none" w="med" len="med"/>
+                      <a:tailEnd type="none" w="med" len="med"/>
+                    </a:lnT>
+                  </a:tcPr>
+                </a:tc>
+                <a:tc>
+                  <a:txBody>
+                    <a:bodyPr/>
+                    <a:lstStyle/>
+                    <a:p>
+                      <a:pPr>
+                        <a:buNone/>
+                      </a:pPr>
+                      <a:endParaRPr lang="ru-RU" sz="2000" dirty="0">
+                        <a:latin typeface="GOST type A" panose="020B0500000000000000" pitchFamily="34" charset="0"/>
+                      </a:endParaRPr>
+                    </a:p>
+                  </a:txBody>
+                  <a:tcPr anchor="ctr">
+                    <a:lnT w="3175" cap="flat" cmpd="sng" algn="ctr">
+                      <a:solidFill>
+                        <a:schemeClr val="tx1"/>
+                      </a:solidFill>
+                      <a:prstDash val="dot"/>
+                      <a:round/>
+                      <a:headEnd type="none" w="med" len="med"/>
+                      <a:tailEnd type="none" w="med" len="med"/>
+                    </a:lnT>
+                  </a:tcPr>
+                </a:tc>
+                <a:extLst>
+                  <a:ext uri="{0D108BD9-81ED-4DB2-BD59-A6C34878D82A}">
+                    <a16:rowId xmlns:a16="http://schemas.microsoft.com/office/drawing/2014/main" val="2153861964"/>
+                  </a:ext>
+                </a:extLst>
+              </a:tr>
+              <a:tr h="544159">
+                <a:tc>
+                  <a:txBody>
+                    <a:bodyPr/>
+                    <a:lstStyle/>
+                    <a:p>
+                      <a:pPr>
+                        <a:buNone/>
+                      </a:pPr>
+                      <a:r>
+                        <a:rPr lang="en-US" sz="2400" b="1" dirty="0">
+                          <a:latin typeface="GOST type A" panose="020B0500000000000000" pitchFamily="34" charset="0"/>
+                        </a:rPr>
+                        <a:t>ResNet50</a:t>
+                      </a:r>
+                      <a:endParaRPr lang="ru-RU" sz="2400" dirty="0">
+                        <a:latin typeface="GOST type A" panose="020B0500000000000000" pitchFamily="34" charset="0"/>
+                      </a:endParaRPr>
+                    </a:p>
+                  </a:txBody>
+                  <a:tcPr anchor="ctr">
+                    <a:lnB w="28575" cap="flat" cmpd="sng" algn="ctr">
+                      <a:solidFill>
+                        <a:schemeClr val="tx1"/>
+                      </a:solidFill>
+                      <a:prstDash val="solid"/>
+                      <a:round/>
+                      <a:headEnd type="none" w="med" len="med"/>
+                      <a:tailEnd type="none" w="med" len="med"/>
+                    </a:lnB>
+                  </a:tcPr>
+                </a:tc>
+                <a:tc>
+                  <a:txBody>
+                    <a:bodyPr/>
+                    <a:lstStyle/>
+                    <a:p>
+                      <a:pPr>
+                        <a:buNone/>
+                      </a:pPr>
+                      <a:r>
+                        <a:rPr lang="ru-RU" sz="2000" dirty="0">
+                          <a:latin typeface="GOST type A" panose="020B0500000000000000" pitchFamily="34" charset="0"/>
+                        </a:rPr>
+                        <a:t>Будет использоваться для поиска визуально похожих иероглифов</a:t>
+                      </a:r>
+                    </a:p>
+                  </a:txBody>
+                  <a:tcPr anchor="ctr">
+                    <a:lnB w="28575" cap="flat" cmpd="sng" algn="ctr">
+                      <a:solidFill>
+                        <a:schemeClr val="tx1"/>
+                      </a:solidFill>
+                      <a:prstDash val="solid"/>
+                      <a:round/>
+                      <a:headEnd type="none" w="med" len="med"/>
+                      <a:tailEnd type="none" w="med" len="med"/>
+                    </a:lnB>
+                  </a:tcPr>
+                </a:tc>
+                <a:extLst>
+                  <a:ext uri="{0D108BD9-81ED-4DB2-BD59-A6C34878D82A}">
+                    <a16:rowId xmlns:a16="http://schemas.microsoft.com/office/drawing/2014/main" val="3976742431"/>
+                  </a:ext>
+                </a:extLst>
+              </a:tr>
+              <a:tr h="0">
+                <a:tc>
+                  <a:txBody>
+                    <a:bodyPr/>
+                    <a:lstStyle/>
+                    <a:p>
+                      <a:pPr>
+                        <a:buNone/>
+                      </a:pPr>
+                      <a:endParaRPr lang="ru-RU" dirty="0"/>
+                    </a:p>
+                  </a:txBody>
+                  <a:tcPr anchor="ctr">
+                    <a:lnT w="28575" cap="flat" cmpd="sng" algn="ctr">
+                      <a:solidFill>
+                        <a:schemeClr val="tx1"/>
+                      </a:solidFill>
+                      <a:prstDash val="solid"/>
+                      <a:round/>
+                      <a:headEnd type="none" w="med" len="med"/>
+                      <a:tailEnd type="none" w="med" len="med"/>
+                    </a:lnT>
+                    <a:lnB w="3175" cap="flat" cmpd="sng" algn="ctr">
+                      <a:noFill/>
+                      <a:prstDash val="dot"/>
+                      <a:round/>
+                      <a:headEnd type="none" w="med" len="med"/>
+                      <a:tailEnd type="none" w="med" len="med"/>
+                    </a:lnB>
+                  </a:tcPr>
+                </a:tc>
+                <a:tc>
+                  <a:txBody>
+                    <a:bodyPr/>
+                    <a:lstStyle/>
+                    <a:p>
+                      <a:pPr>
+                        <a:buNone/>
+                      </a:pPr>
+                      <a:endParaRPr lang="ru-RU" dirty="0"/>
+                    </a:p>
+                  </a:txBody>
+                  <a:tcPr anchor="ctr">
+                    <a:lnT w="28575" cap="flat" cmpd="sng" algn="ctr">
+                      <a:solidFill>
+                        <a:schemeClr val="tx1"/>
+                      </a:solidFill>
+                      <a:prstDash val="solid"/>
+                      <a:round/>
+                      <a:headEnd type="none" w="med" len="med"/>
+                      <a:tailEnd type="none" w="med" len="med"/>
+                    </a:lnT>
+                    <a:lnB w="3175" cap="flat" cmpd="sng" algn="ctr">
+                      <a:noFill/>
+                      <a:prstDash val="dot"/>
+                      <a:round/>
+                      <a:headEnd type="none" w="med" len="med"/>
+                      <a:tailEnd type="none" w="med" len="med"/>
+                    </a:lnB>
+                  </a:tcPr>
+                </a:tc>
+                <a:extLst>
+                  <a:ext uri="{0D108BD9-81ED-4DB2-BD59-A6C34878D82A}">
+                    <a16:rowId xmlns:a16="http://schemas.microsoft.com/office/drawing/2014/main" val="2122417668"/>
+                  </a:ext>
+                </a:extLst>
+              </a:tr>
+            </a:tbl>
+          </a:graphicData>
+        </a:graphic>
+      </p:graphicFrame>
+    </p:spTree>
+    <p:extLst>
+      <p:ext uri="{BB962C8B-B14F-4D97-AF65-F5344CB8AC3E}">
+        <p14:creationId xmlns:p14="http://schemas.microsoft.com/office/powerpoint/2010/main" val="1937175462"/>
+      </p:ext>
+    </p:extLst>
+  </p:cSld>
+  <p:clrMapOvr>
+    <a:masterClrMapping/>
+  </p:clrMapOvr>
+</p:sld>
+</file>
+
+<file path=ppt/slides/slide8.xml><?xml version="1.0" encoding="utf-8"?>
 <p:sld xmlns:a="http://schemas.openxmlformats.org/drawingml/2006/main" xmlns:r="http://schemas.openxmlformats.org/officeDocument/2006/relationships" xmlns:p="http://schemas.openxmlformats.org/presentationml/2006/main">
   <p:cSld>
     <p:spTree>
@@ -11966,396 +13944,10 @@
       </p:grpSpPr>
       <p:sp>
         <p:nvSpPr>
-          <p:cNvPr id="3" name="TextBox 2">
+          <p:cNvPr id="13" name="Прямоугольник 12">
             <a:extLst>
               <a:ext uri="{FF2B5EF4-FFF2-40B4-BE49-F238E27FC236}">
-                <a16:creationId xmlns:a16="http://schemas.microsoft.com/office/drawing/2014/main" id="{A7E884D9-E79E-7E1E-FDD1-286C1D46C3B9}"/>
-              </a:ext>
-            </a:extLst>
-          </p:cNvPr>
-          <p:cNvSpPr txBox="1"/>
-          <p:nvPr/>
-        </p:nvSpPr>
-        <p:spPr>
-          <a:xfrm>
-            <a:off x="5346202" y="286090"/>
-            <a:ext cx="1499594" cy="646331"/>
-          </a:xfrm>
-          <a:prstGeom prst="rect">
-            <a:avLst/>
-          </a:prstGeom>
-          <a:noFill/>
-        </p:spPr>
-        <p:txBody>
-          <a:bodyPr wrap="square">
-            <a:spAutoFit/>
-          </a:bodyPr>
-          <a:lstStyle/>
-          <a:p>
-            <a:r>
-              <a:rPr lang="ru-RU" sz="3600" b="1" dirty="0">
-                <a:latin typeface="GOST type A" panose="020B0500000000000000" pitchFamily="34" charset="0"/>
-              </a:rPr>
-              <a:t>Команда</a:t>
-            </a:r>
-            <a:endParaRPr lang="en-US" sz="3600" b="1" dirty="0">
-              <a:latin typeface="GOST type A" panose="020B0500000000000000" pitchFamily="34" charset="0"/>
-            </a:endParaRPr>
-          </a:p>
-        </p:txBody>
-      </p:sp>
-      <p:pic>
-        <p:nvPicPr>
-          <p:cNvPr id="10" name="Рисунок 9">
-            <a:extLst>
-              <a:ext uri="{FF2B5EF4-FFF2-40B4-BE49-F238E27FC236}">
-                <a16:creationId xmlns:a16="http://schemas.microsoft.com/office/drawing/2014/main" id="{53A4030D-DC26-D362-7D58-B207E38D8535}"/>
-              </a:ext>
-            </a:extLst>
-          </p:cNvPr>
-          <p:cNvPicPr>
-            <a:picLocks noChangeAspect="1"/>
-          </p:cNvPicPr>
-          <p:nvPr/>
-        </p:nvPicPr>
-        <p:blipFill>
-          <a:blip r:embed="rId2">
-            <a:extLst>
-              <a:ext uri="{28A0092B-C50C-407E-A947-70E740481C1C}">
-                <a14:useLocalDpi xmlns:a14="http://schemas.microsoft.com/office/drawing/2010/main" val="0"/>
-              </a:ext>
-            </a:extLst>
-          </a:blip>
-          <a:srcRect/>
-          <a:stretch>
-            <a:fillRect/>
-          </a:stretch>
-        </p:blipFill>
-        <p:spPr>
-          <a:xfrm>
-            <a:off x="1927938" y="1518126"/>
-            <a:ext cx="2988365" cy="2988365"/>
-          </a:xfrm>
-          <a:custGeom>
-            <a:avLst/>
-            <a:gdLst>
-              <a:gd name="csX0" fmla="*/ 1494163 w 2988365"/>
-              <a:gd name="csY0" fmla="*/ 0 h 2988365"/>
-              <a:gd name="csX1" fmla="*/ 1494204 w 2988365"/>
-              <a:gd name="csY1" fmla="*/ 0 h 2988365"/>
-              <a:gd name="csX2" fmla="*/ 1646955 w 2988365"/>
-              <a:gd name="csY2" fmla="*/ 7713 h 2988365"/>
-              <a:gd name="csX3" fmla="*/ 2980652 w 2988365"/>
-              <a:gd name="csY3" fmla="*/ 1341411 h 2988365"/>
-              <a:gd name="csX4" fmla="*/ 2988365 w 2988365"/>
-              <a:gd name="csY4" fmla="*/ 1494163 h 2988365"/>
-              <a:gd name="csX5" fmla="*/ 2988365 w 2988365"/>
-              <a:gd name="csY5" fmla="*/ 1494202 h 2988365"/>
-              <a:gd name="csX6" fmla="*/ 2980652 w 2988365"/>
-              <a:gd name="csY6" fmla="*/ 1646954 h 2988365"/>
-              <a:gd name="csX7" fmla="*/ 1494183 w 2988365"/>
-              <a:gd name="csY7" fmla="*/ 2988365 h 2988365"/>
-              <a:gd name="csX8" fmla="*/ 0 w 2988365"/>
-              <a:gd name="csY8" fmla="*/ 1494182 h 2988365"/>
-              <a:gd name="csX9" fmla="*/ 1341412 w 2988365"/>
-              <a:gd name="csY9" fmla="*/ 7713 h 2988365"/>
-            </a:gdLst>
-            <a:ahLst/>
-            <a:cxnLst>
-              <a:cxn ang="0">
-                <a:pos x="csX0" y="csY0"/>
-              </a:cxn>
-              <a:cxn ang="0">
-                <a:pos x="csX1" y="csY1"/>
-              </a:cxn>
-              <a:cxn ang="0">
-                <a:pos x="csX2" y="csY2"/>
-              </a:cxn>
-              <a:cxn ang="0">
-                <a:pos x="csX3" y="csY3"/>
-              </a:cxn>
-              <a:cxn ang="0">
-                <a:pos x="csX4" y="csY4"/>
-              </a:cxn>
-              <a:cxn ang="0">
-                <a:pos x="csX5" y="csY5"/>
-              </a:cxn>
-              <a:cxn ang="0">
-                <a:pos x="csX6" y="csY6"/>
-              </a:cxn>
-              <a:cxn ang="0">
-                <a:pos x="csX7" y="csY7"/>
-              </a:cxn>
-              <a:cxn ang="0">
-                <a:pos x="csX8" y="csY8"/>
-              </a:cxn>
-              <a:cxn ang="0">
-                <a:pos x="csX9" y="csY9"/>
-              </a:cxn>
-            </a:cxnLst>
-            <a:rect l="l" t="t" r="r" b="b"/>
-            <a:pathLst>
-              <a:path w="2988365" h="2988365">
-                <a:moveTo>
-                  <a:pt x="1494163" y="0"/>
-                </a:moveTo>
-                <a:lnTo>
-                  <a:pt x="1494204" y="0"/>
-                </a:lnTo>
-                <a:lnTo>
-                  <a:pt x="1646955" y="7713"/>
-                </a:lnTo>
-                <a:cubicBezTo>
-                  <a:pt x="2350175" y="79129"/>
-                  <a:pt x="2909236" y="638190"/>
-                  <a:pt x="2980652" y="1341411"/>
-                </a:cubicBezTo>
-                <a:lnTo>
-                  <a:pt x="2988365" y="1494163"/>
-                </a:lnTo>
-                <a:lnTo>
-                  <a:pt x="2988365" y="1494202"/>
-                </a:lnTo>
-                <a:lnTo>
-                  <a:pt x="2980652" y="1646954"/>
-                </a:lnTo>
-                <a:cubicBezTo>
-                  <a:pt x="2904135" y="2400404"/>
-                  <a:pt x="2267821" y="2988365"/>
-                  <a:pt x="1494183" y="2988365"/>
-                </a:cubicBezTo>
-                <a:cubicBezTo>
-                  <a:pt x="668969" y="2988365"/>
-                  <a:pt x="0" y="2319396"/>
-                  <a:pt x="0" y="1494182"/>
-                </a:cubicBezTo>
-                <a:cubicBezTo>
-                  <a:pt x="0" y="720544"/>
-                  <a:pt x="587961" y="84231"/>
-                  <a:pt x="1341412" y="7713"/>
-                </a:cubicBezTo>
-                <a:close/>
-              </a:path>
-            </a:pathLst>
-          </a:custGeom>
-        </p:spPr>
-      </p:pic>
-      <p:pic>
-        <p:nvPicPr>
-          <p:cNvPr id="14" name="Рисунок 13">
-            <a:extLst>
-              <a:ext uri="{FF2B5EF4-FFF2-40B4-BE49-F238E27FC236}">
-                <a16:creationId xmlns:a16="http://schemas.microsoft.com/office/drawing/2014/main" id="{1FC942D5-4FD6-AC52-96D2-29F45352E8F1}"/>
-              </a:ext>
-            </a:extLst>
-          </p:cNvPr>
-          <p:cNvPicPr>
-            <a:picLocks noChangeAspect="1"/>
-          </p:cNvPicPr>
-          <p:nvPr/>
-        </p:nvPicPr>
-        <p:blipFill>
-          <a:blip r:embed="rId3"/>
-          <a:srcRect/>
-          <a:stretch>
-            <a:fillRect/>
-          </a:stretch>
-        </p:blipFill>
-        <p:spPr>
-          <a:xfrm>
-            <a:off x="6947131" y="1552851"/>
-            <a:ext cx="2988364" cy="2988365"/>
-          </a:xfrm>
-          <a:custGeom>
-            <a:avLst/>
-            <a:gdLst>
-              <a:gd name="csX0" fmla="*/ 1494163 w 2988364"/>
-              <a:gd name="csY0" fmla="*/ 0 h 2988365"/>
-              <a:gd name="csX1" fmla="*/ 1494204 w 2988364"/>
-              <a:gd name="csY1" fmla="*/ 0 h 2988365"/>
-              <a:gd name="csX2" fmla="*/ 1646955 w 2988364"/>
-              <a:gd name="csY2" fmla="*/ 7713 h 2988365"/>
-              <a:gd name="csX3" fmla="*/ 2980652 w 2988364"/>
-              <a:gd name="csY3" fmla="*/ 1341411 h 2988365"/>
-              <a:gd name="csX4" fmla="*/ 2988364 w 2988364"/>
-              <a:gd name="csY4" fmla="*/ 1494144 h 2988365"/>
-              <a:gd name="csX5" fmla="*/ 2988364 w 2988364"/>
-              <a:gd name="csY5" fmla="*/ 1494222 h 2988365"/>
-              <a:gd name="csX6" fmla="*/ 2980652 w 2988364"/>
-              <a:gd name="csY6" fmla="*/ 1646954 h 2988365"/>
-              <a:gd name="csX7" fmla="*/ 1494183 w 2988364"/>
-              <a:gd name="csY7" fmla="*/ 2988365 h 2988365"/>
-              <a:gd name="csX8" fmla="*/ 0 w 2988364"/>
-              <a:gd name="csY8" fmla="*/ 1494182 h 2988365"/>
-              <a:gd name="csX9" fmla="*/ 1341412 w 2988364"/>
-              <a:gd name="csY9" fmla="*/ 7713 h 2988365"/>
-            </a:gdLst>
-            <a:ahLst/>
-            <a:cxnLst>
-              <a:cxn ang="0">
-                <a:pos x="csX0" y="csY0"/>
-              </a:cxn>
-              <a:cxn ang="0">
-                <a:pos x="csX1" y="csY1"/>
-              </a:cxn>
-              <a:cxn ang="0">
-                <a:pos x="csX2" y="csY2"/>
-              </a:cxn>
-              <a:cxn ang="0">
-                <a:pos x="csX3" y="csY3"/>
-              </a:cxn>
-              <a:cxn ang="0">
-                <a:pos x="csX4" y="csY4"/>
-              </a:cxn>
-              <a:cxn ang="0">
-                <a:pos x="csX5" y="csY5"/>
-              </a:cxn>
-              <a:cxn ang="0">
-                <a:pos x="csX6" y="csY6"/>
-              </a:cxn>
-              <a:cxn ang="0">
-                <a:pos x="csX7" y="csY7"/>
-              </a:cxn>
-              <a:cxn ang="0">
-                <a:pos x="csX8" y="csY8"/>
-              </a:cxn>
-              <a:cxn ang="0">
-                <a:pos x="csX9" y="csY9"/>
-              </a:cxn>
-            </a:cxnLst>
-            <a:rect l="l" t="t" r="r" b="b"/>
-            <a:pathLst>
-              <a:path w="2988364" h="2988365">
-                <a:moveTo>
-                  <a:pt x="1494163" y="0"/>
-                </a:moveTo>
-                <a:lnTo>
-                  <a:pt x="1494204" y="0"/>
-                </a:lnTo>
-                <a:lnTo>
-                  <a:pt x="1646955" y="7713"/>
-                </a:lnTo>
-                <a:cubicBezTo>
-                  <a:pt x="2350175" y="79129"/>
-                  <a:pt x="2909236" y="638190"/>
-                  <a:pt x="2980652" y="1341411"/>
-                </a:cubicBezTo>
-                <a:lnTo>
-                  <a:pt x="2988364" y="1494144"/>
-                </a:lnTo>
-                <a:lnTo>
-                  <a:pt x="2988364" y="1494222"/>
-                </a:lnTo>
-                <a:lnTo>
-                  <a:pt x="2980652" y="1646954"/>
-                </a:lnTo>
-                <a:cubicBezTo>
-                  <a:pt x="2904135" y="2400404"/>
-                  <a:pt x="2267821" y="2988365"/>
-                  <a:pt x="1494183" y="2988365"/>
-                </a:cubicBezTo>
-                <a:cubicBezTo>
-                  <a:pt x="668969" y="2988365"/>
-                  <a:pt x="0" y="2319396"/>
-                  <a:pt x="0" y="1494182"/>
-                </a:cubicBezTo>
-                <a:cubicBezTo>
-                  <a:pt x="0" y="720544"/>
-                  <a:pt x="587961" y="84231"/>
-                  <a:pt x="1341412" y="7713"/>
-                </a:cubicBezTo>
-                <a:close/>
-              </a:path>
-            </a:pathLst>
-          </a:custGeom>
-        </p:spPr>
-      </p:pic>
-      <p:sp>
-        <p:nvSpPr>
-          <p:cNvPr id="17" name="TextBox 16">
-            <a:extLst>
-              <a:ext uri="{FF2B5EF4-FFF2-40B4-BE49-F238E27FC236}">
-                <a16:creationId xmlns:a16="http://schemas.microsoft.com/office/drawing/2014/main" id="{6C4F2015-6597-59CD-8024-2D1B0DABAFD5}"/>
-              </a:ext>
-            </a:extLst>
-          </p:cNvPr>
-          <p:cNvSpPr txBox="1"/>
-          <p:nvPr/>
-        </p:nvSpPr>
-        <p:spPr>
-          <a:xfrm>
-            <a:off x="2207999" y="4819005"/>
-            <a:ext cx="2491323" cy="461665"/>
-          </a:xfrm>
-          <a:prstGeom prst="rect">
-            <a:avLst/>
-          </a:prstGeom>
-          <a:noFill/>
-        </p:spPr>
-        <p:txBody>
-          <a:bodyPr wrap="square">
-            <a:spAutoFit/>
-          </a:bodyPr>
-          <a:lstStyle/>
-          <a:p>
-            <a:r>
-              <a:rPr lang="ru-RU" sz="2400" dirty="0">
-                <a:latin typeface="GOST type A" panose="020B0500000000000000" pitchFamily="34" charset="0"/>
-              </a:rPr>
-              <a:t>Смирнова Анастасия</a:t>
-            </a:r>
-            <a:endParaRPr lang="en-US" sz="2400" dirty="0">
-              <a:latin typeface="GOST type A" panose="020B0500000000000000" pitchFamily="34" charset="0"/>
-            </a:endParaRPr>
-          </a:p>
-        </p:txBody>
-      </p:sp>
-      <p:sp>
-        <p:nvSpPr>
-          <p:cNvPr id="19" name="TextBox 18">
-            <a:extLst>
-              <a:ext uri="{FF2B5EF4-FFF2-40B4-BE49-F238E27FC236}">
-                <a16:creationId xmlns:a16="http://schemas.microsoft.com/office/drawing/2014/main" id="{1B51DC4F-23D4-1220-816F-8FE7B607DDC5}"/>
-              </a:ext>
-            </a:extLst>
-          </p:cNvPr>
-          <p:cNvSpPr txBox="1"/>
-          <p:nvPr/>
-        </p:nvSpPr>
-        <p:spPr>
-          <a:xfrm>
-            <a:off x="7521932" y="4853729"/>
-            <a:ext cx="1988722" cy="461665"/>
-          </a:xfrm>
-          <a:prstGeom prst="rect">
-            <a:avLst/>
-          </a:prstGeom>
-          <a:noFill/>
-        </p:spPr>
-        <p:txBody>
-          <a:bodyPr wrap="square">
-            <a:spAutoFit/>
-          </a:bodyPr>
-          <a:lstStyle/>
-          <a:p>
-            <a:r>
-              <a:rPr lang="ru-RU" sz="2400" dirty="0">
-                <a:latin typeface="GOST type A" panose="020B0500000000000000" pitchFamily="34" charset="0"/>
-              </a:rPr>
-              <a:t>Морозова Софья</a:t>
-            </a:r>
-            <a:endParaRPr lang="en-US" sz="2400" dirty="0">
-              <a:latin typeface="GOST type A" panose="020B0500000000000000" pitchFamily="34" charset="0"/>
-            </a:endParaRPr>
-          </a:p>
-        </p:txBody>
-      </p:sp>
-      <p:sp>
-        <p:nvSpPr>
-          <p:cNvPr id="20" name="Овал 19">
-            <a:extLst>
-              <a:ext uri="{FF2B5EF4-FFF2-40B4-BE49-F238E27FC236}">
-                <a16:creationId xmlns:a16="http://schemas.microsoft.com/office/drawing/2014/main" id="{0CEC7A96-2EE1-7697-F92D-EB913742AF4A}"/>
+                <a16:creationId xmlns:a16="http://schemas.microsoft.com/office/drawing/2014/main" id="{B168DC79-B636-D5C8-AC75-D5753880C1E5}"/>
               </a:ext>
             </a:extLst>
           </p:cNvPr>
@@ -12364,88 +13956,25 @@
         </p:nvSpPr>
         <p:spPr>
           <a:xfrm>
-            <a:off x="1761153" y="1340814"/>
-            <a:ext cx="3321934" cy="3321934"/>
+            <a:off x="1226916" y="-12680"/>
+            <a:ext cx="405114" cy="6870680"/>
           </a:xfrm>
-          <a:custGeom>
+          <a:prstGeom prst="rect">
             <a:avLst/>
-            <a:gdLst>
-              <a:gd name="csX0" fmla="*/ 0 w 3321934"/>
-              <a:gd name="csY0" fmla="*/ 1660967 h 3321934"/>
-              <a:gd name="csX1" fmla="*/ 1660967 w 3321934"/>
-              <a:gd name="csY1" fmla="*/ 0 h 3321934"/>
-              <a:gd name="csX2" fmla="*/ 3321934 w 3321934"/>
-              <a:gd name="csY2" fmla="*/ 1660967 h 3321934"/>
-              <a:gd name="csX3" fmla="*/ 1660967 w 3321934"/>
-              <a:gd name="csY3" fmla="*/ 3321934 h 3321934"/>
-              <a:gd name="csX4" fmla="*/ 0 w 3321934"/>
-              <a:gd name="csY4" fmla="*/ 1660967 h 3321934"/>
-            </a:gdLst>
-            <a:ahLst/>
-            <a:cxnLst>
-              <a:cxn ang="0">
-                <a:pos x="csX0" y="csY0"/>
-              </a:cxn>
-              <a:cxn ang="0">
-                <a:pos x="csX1" y="csY1"/>
-              </a:cxn>
-              <a:cxn ang="0">
-                <a:pos x="csX2" y="csY2"/>
-              </a:cxn>
-              <a:cxn ang="0">
-                <a:pos x="csX3" y="csY3"/>
-              </a:cxn>
-              <a:cxn ang="0">
-                <a:pos x="csX4" y="csY4"/>
-              </a:cxn>
-            </a:cxnLst>
-            <a:rect l="l" t="t" r="r" b="b"/>
-            <a:pathLst>
-              <a:path w="3321934" h="3321934" extrusionOk="0">
-                <a:moveTo>
-                  <a:pt x="0" y="1660967"/>
-                </a:moveTo>
-                <a:cubicBezTo>
-                  <a:pt x="-167409" y="803095"/>
-                  <a:pt x="949676" y="-96355"/>
-                  <a:pt x="1660967" y="0"/>
-                </a:cubicBezTo>
-                <a:cubicBezTo>
-                  <a:pt x="2550306" y="-18993"/>
-                  <a:pt x="3525890" y="728169"/>
-                  <a:pt x="3321934" y="1660967"/>
-                </a:cubicBezTo>
-                <a:cubicBezTo>
-                  <a:pt x="3382536" y="2527150"/>
-                  <a:pt x="2543303" y="3312466"/>
-                  <a:pt x="1660967" y="3321934"/>
-                </a:cubicBezTo>
-                <a:cubicBezTo>
-                  <a:pt x="921803" y="3319541"/>
-                  <a:pt x="3369" y="2534635"/>
-                  <a:pt x="0" y="1660967"/>
-                </a:cubicBezTo>
-                <a:close/>
-              </a:path>
-            </a:pathLst>
-          </a:custGeom>
-          <a:noFill/>
-          <a:ln w="38100">
-            <a:solidFill>
-              <a:schemeClr val="tx1"/>
-            </a:solidFill>
-            <a:extLst>
-              <a:ext uri="{C807C97D-BFC1-408E-A445-0C87EB9F89A2}">
-                <ask:lineSketchStyleProps xmlns:ask="http://schemas.microsoft.com/office/drawing/2018/sketchyshapes" sd="1207386977">
-                  <a:prstGeom prst="ellipse">
-                    <a:avLst/>
-                  </a:prstGeom>
-                  <ask:type>
-                    <ask:lineSketchFreehand/>
-                  </ask:type>
-                </ask:lineSketchStyleProps>
-              </a:ext>
-            </a:extLst>
+          </a:prstGeom>
+          <a:gradFill>
+            <a:gsLst>
+              <a:gs pos="0">
+                <a:srgbClr val="E6E5E3"/>
+              </a:gs>
+              <a:gs pos="77000">
+                <a:srgbClr val="C2BCAE"/>
+              </a:gs>
+            </a:gsLst>
+            <a:lin ang="5400000" scaled="1"/>
+          </a:gradFill>
+          <a:ln>
+            <a:noFill/>
           </a:ln>
         </p:spPr>
         <p:style>
@@ -12473,12 +14002,287 @@
           </a:p>
         </p:txBody>
       </p:sp>
+      <p:pic>
+        <p:nvPicPr>
+          <p:cNvPr id="2052" name="Picture 4">
+            <a:extLst>
+              <a:ext uri="{FF2B5EF4-FFF2-40B4-BE49-F238E27FC236}">
+                <a16:creationId xmlns:a16="http://schemas.microsoft.com/office/drawing/2014/main" id="{460A0856-BFCE-D84E-F30E-906A5BCFD13B}"/>
+              </a:ext>
+            </a:extLst>
+          </p:cNvPr>
+          <p:cNvPicPr>
+            <a:picLocks noChangeAspect="1" noChangeArrowheads="1"/>
+          </p:cNvPicPr>
+          <p:nvPr/>
+        </p:nvPicPr>
+        <p:blipFill>
+          <a:blip r:embed="rId2">
+            <a:extLst>
+              <a:ext uri="{28A0092B-C50C-407E-A947-70E740481C1C}">
+                <a14:useLocalDpi xmlns:a14="http://schemas.microsoft.com/office/drawing/2010/main" val="0"/>
+              </a:ext>
+            </a:extLst>
+          </a:blip>
+          <a:srcRect/>
+          <a:stretch>
+            <a:fillRect/>
+          </a:stretch>
+        </p:blipFill>
+        <p:spPr bwMode="auto">
+          <a:xfrm>
+            <a:off x="7631113" y="-12680"/>
+            <a:ext cx="4560887" cy="6870680"/>
+          </a:xfrm>
+          <a:prstGeom prst="rect">
+            <a:avLst/>
+          </a:prstGeom>
+          <a:noFill/>
+          <a:extLst>
+            <a:ext uri="{909E8E84-426E-40DD-AFC4-6F175D3DCCD1}">
+              <a14:hiddenFill xmlns:a14="http://schemas.microsoft.com/office/drawing/2010/main">
+                <a:solidFill>
+                  <a:srgbClr val="FFFFFF"/>
+                </a:solidFill>
+              </a14:hiddenFill>
+            </a:ext>
+          </a:extLst>
+        </p:spPr>
+      </p:pic>
       <p:sp>
         <p:nvSpPr>
-          <p:cNvPr id="21" name="Овал 20">
+          <p:cNvPr id="4" name="TextBox 3">
             <a:extLst>
               <a:ext uri="{FF2B5EF4-FFF2-40B4-BE49-F238E27FC236}">
-                <a16:creationId xmlns:a16="http://schemas.microsoft.com/office/drawing/2014/main" id="{8E026563-CC01-5200-C36A-8B07E1BF0EF5}"/>
+                <a16:creationId xmlns:a16="http://schemas.microsoft.com/office/drawing/2014/main" id="{A19E1313-51C8-DB55-B0B0-8FBF64DE5B8C}"/>
+              </a:ext>
+            </a:extLst>
+          </p:cNvPr>
+          <p:cNvSpPr txBox="1"/>
+          <p:nvPr/>
+        </p:nvSpPr>
+        <p:spPr>
+          <a:xfrm>
+            <a:off x="7683052" y="3037939"/>
+            <a:ext cx="1976083" cy="769441"/>
+          </a:xfrm>
+          <a:prstGeom prst="rect">
+            <a:avLst/>
+          </a:prstGeom>
+          <a:noFill/>
+        </p:spPr>
+        <p:txBody>
+          <a:bodyPr wrap="square">
+            <a:spAutoFit/>
+          </a:bodyPr>
+          <a:lstStyle/>
+          <a:p>
+            <a:r>
+              <a:rPr lang="ru-RU" sz="4400" b="1" dirty="0">
+                <a:latin typeface="GOST type A" panose="020B0500000000000000" pitchFamily="34" charset="0"/>
+              </a:rPr>
+              <a:t>Метрики</a:t>
+            </a:r>
+            <a:endParaRPr lang="en-US" sz="4400" b="1" dirty="0">
+              <a:latin typeface="GOST type A" panose="020B0500000000000000" pitchFamily="34" charset="0"/>
+            </a:endParaRPr>
+          </a:p>
+        </p:txBody>
+      </p:sp>
+      <p:sp>
+        <p:nvSpPr>
+          <p:cNvPr id="6" name="TextBox 5">
+            <a:extLst>
+              <a:ext uri="{FF2B5EF4-FFF2-40B4-BE49-F238E27FC236}">
+                <a16:creationId xmlns:a16="http://schemas.microsoft.com/office/drawing/2014/main" id="{01AE136C-6D9D-C5BC-E884-A2B9FDD42F5C}"/>
+              </a:ext>
+            </a:extLst>
+          </p:cNvPr>
+          <p:cNvSpPr txBox="1"/>
+          <p:nvPr/>
+        </p:nvSpPr>
+        <p:spPr>
+          <a:xfrm>
+            <a:off x="1909717" y="753672"/>
+            <a:ext cx="5710450" cy="2000548"/>
+          </a:xfrm>
+          <a:prstGeom prst="rect">
+            <a:avLst/>
+          </a:prstGeom>
+          <a:noFill/>
+        </p:spPr>
+        <p:txBody>
+          <a:bodyPr wrap="square">
+            <a:spAutoFit/>
+          </a:bodyPr>
+          <a:lstStyle/>
+          <a:p>
+            <a:pPr>
+              <a:buNone/>
+            </a:pPr>
+            <a:r>
+              <a:rPr lang="ru-RU" sz="2800" b="1" dirty="0">
+                <a:latin typeface="GOST type A" panose="020B0500000000000000" pitchFamily="34" charset="0"/>
+              </a:rPr>
+              <a:t>Метрики производительности (системные)</a:t>
+            </a:r>
+          </a:p>
+          <a:p>
+            <a:pPr marL="342900" indent="-342900">
+              <a:buFont typeface="Arial" panose="020B0604020202020204" pitchFamily="34" charset="0"/>
+              <a:buChar char="•"/>
+            </a:pPr>
+            <a:r>
+              <a:rPr lang="ru-RU" sz="2400" dirty="0">
+                <a:latin typeface="GOST type A" panose="020B0500000000000000" pitchFamily="34" charset="0"/>
+              </a:rPr>
+              <a:t> Время ответа API (цель &lt; 500 мс)</a:t>
+            </a:r>
+          </a:p>
+          <a:p>
+            <a:pPr marL="342900" indent="-342900">
+              <a:buFont typeface="Arial" panose="020B0604020202020204" pitchFamily="34" charset="0"/>
+              <a:buChar char="•"/>
+            </a:pPr>
+            <a:r>
+              <a:rPr lang="ru-RU" sz="2400" dirty="0">
+                <a:latin typeface="GOST type A" panose="020B0500000000000000" pitchFamily="34" charset="0"/>
+              </a:rPr>
+              <a:t> Время поиска в </a:t>
+            </a:r>
+            <a:r>
+              <a:rPr lang="ru-RU" sz="2400" dirty="0" err="1">
+                <a:latin typeface="GOST type A" panose="020B0500000000000000" pitchFamily="34" charset="0"/>
+              </a:rPr>
+              <a:t>SQLite</a:t>
+            </a:r>
+            <a:r>
+              <a:rPr lang="ru-RU" sz="2400" dirty="0">
+                <a:latin typeface="GOST type A" panose="020B0500000000000000" pitchFamily="34" charset="0"/>
+              </a:rPr>
+              <a:t> среди 21 056 иероглифов</a:t>
+            </a:r>
+          </a:p>
+          <a:p>
+            <a:pPr marL="342900" indent="-342900">
+              <a:buFont typeface="Arial" panose="020B0604020202020204" pitchFamily="34" charset="0"/>
+              <a:buChar char="•"/>
+            </a:pPr>
+            <a:r>
+              <a:rPr lang="ru-RU" sz="2400" dirty="0">
+                <a:latin typeface="GOST type A" panose="020B0500000000000000" pitchFamily="34" charset="0"/>
+              </a:rPr>
+              <a:t> Нагрузка на CPU/RAM</a:t>
+            </a:r>
+          </a:p>
+        </p:txBody>
+      </p:sp>
+      <p:sp>
+        <p:nvSpPr>
+          <p:cNvPr id="10" name="TextBox 9">
+            <a:extLst>
+              <a:ext uri="{FF2B5EF4-FFF2-40B4-BE49-F238E27FC236}">
+                <a16:creationId xmlns:a16="http://schemas.microsoft.com/office/drawing/2014/main" id="{DBAD3CEB-D0AB-8E76-BB2D-74AEC3C183A3}"/>
+              </a:ext>
+            </a:extLst>
+          </p:cNvPr>
+          <p:cNvSpPr txBox="1"/>
+          <p:nvPr/>
+        </p:nvSpPr>
+        <p:spPr>
+          <a:xfrm>
+            <a:off x="1909717" y="3037939"/>
+            <a:ext cx="5818019" cy="3108543"/>
+          </a:xfrm>
+          <a:prstGeom prst="rect">
+            <a:avLst/>
+          </a:prstGeom>
+          <a:noFill/>
+        </p:spPr>
+        <p:txBody>
+          <a:bodyPr wrap="square">
+            <a:spAutoFit/>
+          </a:bodyPr>
+          <a:lstStyle/>
+          <a:p>
+            <a:pPr>
+              <a:buNone/>
+            </a:pPr>
+            <a:r>
+              <a:rPr lang="ru-RU" sz="2800" b="1" dirty="0">
+                <a:latin typeface="GOST type A" panose="020B0500000000000000" pitchFamily="34" charset="0"/>
+              </a:rPr>
+              <a:t>Бизнес-метрики</a:t>
+            </a:r>
+          </a:p>
+          <a:p>
+            <a:pPr marL="342900" indent="-342900">
+              <a:buFont typeface="Arial" panose="020B0604020202020204" pitchFamily="34" charset="0"/>
+              <a:buChar char="•"/>
+            </a:pPr>
+            <a:r>
+              <a:rPr lang="ru-RU" sz="2400" dirty="0">
+                <a:latin typeface="GOST type A" panose="020B0500000000000000" pitchFamily="34" charset="0"/>
+              </a:rPr>
+              <a:t> DAU / MAU — ежедневные/ежемесячные активные пользователи</a:t>
+            </a:r>
+          </a:p>
+          <a:p>
+            <a:pPr marL="342900" indent="-342900">
+              <a:buFont typeface="Arial" panose="020B0604020202020204" pitchFamily="34" charset="0"/>
+              <a:buChar char="•"/>
+            </a:pPr>
+            <a:r>
+              <a:rPr lang="ru-RU" sz="2400" dirty="0">
+                <a:latin typeface="GOST type A" panose="020B0500000000000000" pitchFamily="34" charset="0"/>
+              </a:rPr>
+              <a:t> Среднее количество поисков на пользователя</a:t>
+            </a:r>
+          </a:p>
+          <a:p>
+            <a:pPr marL="342900" indent="-342900">
+              <a:buFont typeface="Arial" panose="020B0604020202020204" pitchFamily="34" charset="0"/>
+              <a:buChar char="•"/>
+            </a:pPr>
+            <a:r>
+              <a:rPr lang="ru-RU" sz="2400" dirty="0">
+                <a:latin typeface="GOST type A" panose="020B0500000000000000" pitchFamily="34" charset="0"/>
+              </a:rPr>
+              <a:t> </a:t>
+            </a:r>
+            <a:r>
+              <a:rPr lang="ru-RU" sz="2400" dirty="0" err="1">
+                <a:latin typeface="GOST type A" panose="020B0500000000000000" pitchFamily="34" charset="0"/>
+              </a:rPr>
+              <a:t>Retention</a:t>
+            </a:r>
+            <a:r>
+              <a:rPr lang="ru-RU" sz="2400" dirty="0">
+                <a:latin typeface="GOST type A" panose="020B0500000000000000" pitchFamily="34" charset="0"/>
+              </a:rPr>
+              <a:t> (Day 1, Day 7) — возвращаются ли на следующий день/неделю</a:t>
+            </a:r>
+          </a:p>
+          <a:p>
+            <a:pPr marL="342900" indent="-342900">
+              <a:buFont typeface="Arial" panose="020B0604020202020204" pitchFamily="34" charset="0"/>
+              <a:buChar char="•"/>
+            </a:pPr>
+            <a:r>
+              <a:rPr lang="ru-RU" sz="2400" dirty="0">
+                <a:latin typeface="GOST type A" panose="020B0500000000000000" pitchFamily="34" charset="0"/>
+              </a:rPr>
+              <a:t> CTR (клики по найденным иероглифам) — полезен ли поиск</a:t>
+            </a:r>
+          </a:p>
+        </p:txBody>
+      </p:sp>
+      <p:sp>
+        <p:nvSpPr>
+          <p:cNvPr id="16" name="Прямоугольник 15">
+            <a:extLst>
+              <a:ext uri="{FF2B5EF4-FFF2-40B4-BE49-F238E27FC236}">
+                <a16:creationId xmlns:a16="http://schemas.microsoft.com/office/drawing/2014/main" id="{19F75295-D645-65F7-0FDE-02C9F79E7970}"/>
               </a:ext>
             </a:extLst>
           </p:cNvPr>
@@ -12486,89 +14290,29 @@
           <p:nvPr/>
         </p:nvSpPr>
         <p:spPr>
-          <a:xfrm rot="2891641">
-            <a:off x="6780346" y="1386065"/>
-            <a:ext cx="3321934" cy="3321934"/>
+          <a:xfrm>
+            <a:off x="949229" y="753672"/>
+            <a:ext cx="405113" cy="6104328"/>
           </a:xfrm>
-          <a:custGeom>
+          <a:prstGeom prst="rect">
             <a:avLst/>
-            <a:gdLst>
-              <a:gd name="csX0" fmla="*/ 0 w 3321934"/>
-              <a:gd name="csY0" fmla="*/ 1660967 h 3321934"/>
-              <a:gd name="csX1" fmla="*/ 1660967 w 3321934"/>
-              <a:gd name="csY1" fmla="*/ 0 h 3321934"/>
-              <a:gd name="csX2" fmla="*/ 3321934 w 3321934"/>
-              <a:gd name="csY2" fmla="*/ 1660967 h 3321934"/>
-              <a:gd name="csX3" fmla="*/ 1660967 w 3321934"/>
-              <a:gd name="csY3" fmla="*/ 3321934 h 3321934"/>
-              <a:gd name="csX4" fmla="*/ 0 w 3321934"/>
-              <a:gd name="csY4" fmla="*/ 1660967 h 3321934"/>
-            </a:gdLst>
-            <a:ahLst/>
-            <a:cxnLst>
-              <a:cxn ang="0">
-                <a:pos x="csX0" y="csY0"/>
-              </a:cxn>
-              <a:cxn ang="0">
-                <a:pos x="csX1" y="csY1"/>
-              </a:cxn>
-              <a:cxn ang="0">
-                <a:pos x="csX2" y="csY2"/>
-              </a:cxn>
-              <a:cxn ang="0">
-                <a:pos x="csX3" y="csY3"/>
-              </a:cxn>
-              <a:cxn ang="0">
-                <a:pos x="csX4" y="csY4"/>
-              </a:cxn>
-            </a:cxnLst>
-            <a:rect l="l" t="t" r="r" b="b"/>
-            <a:pathLst>
-              <a:path w="3321934" h="3321934" extrusionOk="0">
-                <a:moveTo>
-                  <a:pt x="0" y="1660967"/>
-                </a:moveTo>
-                <a:cubicBezTo>
-                  <a:pt x="-167409" y="803095"/>
-                  <a:pt x="949676" y="-96355"/>
-                  <a:pt x="1660967" y="0"/>
-                </a:cubicBezTo>
-                <a:cubicBezTo>
-                  <a:pt x="2550306" y="-18993"/>
-                  <a:pt x="3525890" y="728169"/>
-                  <a:pt x="3321934" y="1660967"/>
-                </a:cubicBezTo>
-                <a:cubicBezTo>
-                  <a:pt x="3382536" y="2527150"/>
-                  <a:pt x="2543303" y="3312466"/>
-                  <a:pt x="1660967" y="3321934"/>
-                </a:cubicBezTo>
-                <a:cubicBezTo>
-                  <a:pt x="921803" y="3319541"/>
-                  <a:pt x="3369" y="2534635"/>
-                  <a:pt x="0" y="1660967"/>
-                </a:cubicBezTo>
-                <a:close/>
-              </a:path>
-            </a:pathLst>
-          </a:custGeom>
-          <a:noFill/>
-          <a:ln w="38100">
-            <a:solidFill>
-              <a:schemeClr val="tx1"/>
-            </a:solidFill>
-            <a:extLst>
-              <a:ext uri="{C807C97D-BFC1-408E-A445-0C87EB9F89A2}">
-                <ask:lineSketchStyleProps xmlns:ask="http://schemas.microsoft.com/office/drawing/2018/sketchyshapes" sd="1207386977">
-                  <a:prstGeom prst="ellipse">
-                    <a:avLst/>
-                  </a:prstGeom>
-                  <ask:type>
-                    <ask:lineSketchFreehand/>
-                  </ask:type>
-                </ask:lineSketchStyleProps>
-              </a:ext>
-            </a:extLst>
+          </a:prstGeom>
+          <a:gradFill>
+            <a:gsLst>
+              <a:gs pos="37000">
+                <a:srgbClr val="E6E5E3"/>
+              </a:gs>
+              <a:gs pos="0">
+                <a:schemeClr val="bg1"/>
+              </a:gs>
+              <a:gs pos="73000">
+                <a:srgbClr val="C2BCAE"/>
+              </a:gs>
+            </a:gsLst>
+            <a:lin ang="5400000" scaled="1"/>
+          </a:gradFill>
+          <a:ln>
+            <a:noFill/>
           </a:ln>
         </p:spPr>
         <p:style>
@@ -12598,10 +14342,329 @@
       </p:sp>
       <p:sp>
         <p:nvSpPr>
-          <p:cNvPr id="25" name="TextBox 24">
+          <p:cNvPr id="17" name="Прямоугольник 16">
             <a:extLst>
               <a:ext uri="{FF2B5EF4-FFF2-40B4-BE49-F238E27FC236}">
-                <a16:creationId xmlns:a16="http://schemas.microsoft.com/office/drawing/2014/main" id="{A30F3D50-C6E3-9CDB-92A9-B49C94E2DBA5}"/>
+                <a16:creationId xmlns:a16="http://schemas.microsoft.com/office/drawing/2014/main" id="{4FDF35F9-C838-152F-925C-FED4EF1217E9}"/>
+              </a:ext>
+            </a:extLst>
+          </p:cNvPr>
+          <p:cNvSpPr/>
+          <p:nvPr/>
+        </p:nvSpPr>
+        <p:spPr>
+          <a:xfrm rot="10800000">
+            <a:off x="7417610" y="-3219823"/>
+            <a:ext cx="405113" cy="6104328"/>
+          </a:xfrm>
+          <a:prstGeom prst="rect">
+            <a:avLst/>
+          </a:prstGeom>
+          <a:gradFill>
+            <a:gsLst>
+              <a:gs pos="37000">
+                <a:srgbClr val="E6E5E3"/>
+              </a:gs>
+              <a:gs pos="0">
+                <a:schemeClr val="bg1"/>
+              </a:gs>
+              <a:gs pos="73000">
+                <a:srgbClr val="C2BCAE"/>
+              </a:gs>
+            </a:gsLst>
+            <a:lin ang="5400000" scaled="1"/>
+          </a:gradFill>
+          <a:ln>
+            <a:noFill/>
+          </a:ln>
+        </p:spPr>
+        <p:style>
+          <a:lnRef idx="2">
+            <a:schemeClr val="accent1">
+              <a:shade val="15000"/>
+            </a:schemeClr>
+          </a:lnRef>
+          <a:fillRef idx="1">
+            <a:schemeClr val="accent1"/>
+          </a:fillRef>
+          <a:effectRef idx="0">
+            <a:schemeClr val="accent1"/>
+          </a:effectRef>
+          <a:fontRef idx="minor">
+            <a:schemeClr val="lt1"/>
+          </a:fontRef>
+        </p:style>
+        <p:txBody>
+          <a:bodyPr rtlCol="0" anchor="ctr"/>
+          <a:lstStyle/>
+          <a:p>
+            <a:pPr algn="ctr"/>
+            <a:endParaRPr lang="en-US"/>
+          </a:p>
+        </p:txBody>
+      </p:sp>
+    </p:spTree>
+    <p:extLst>
+      <p:ext uri="{BB962C8B-B14F-4D97-AF65-F5344CB8AC3E}">
+        <p14:creationId xmlns:p14="http://schemas.microsoft.com/office/powerpoint/2010/main" val="265871849"/>
+      </p:ext>
+    </p:extLst>
+  </p:cSld>
+  <p:clrMapOvr>
+    <a:masterClrMapping/>
+  </p:clrMapOvr>
+</p:sld>
+</file>
+
+<file path=ppt/slides/slide9.xml><?xml version="1.0" encoding="utf-8"?>
+<p:sld xmlns:a="http://schemas.openxmlformats.org/drawingml/2006/main" xmlns:r="http://schemas.openxmlformats.org/officeDocument/2006/relationships" xmlns:p="http://schemas.openxmlformats.org/presentationml/2006/main">
+  <p:cSld>
+    <p:spTree>
+      <p:nvGrpSpPr>
+        <p:cNvPr id="1" name=""/>
+        <p:cNvGrpSpPr/>
+        <p:nvPr/>
+      </p:nvGrpSpPr>
+      <p:grpSpPr>
+        <a:xfrm>
+          <a:off x="0" y="0"/>
+          <a:ext cx="0" cy="0"/>
+          <a:chOff x="0" y="0"/>
+          <a:chExt cx="0" cy="0"/>
+        </a:xfrm>
+      </p:grpSpPr>
+      <p:sp>
+        <p:nvSpPr>
+          <p:cNvPr id="13" name="Прямоугольник 12">
+            <a:extLst>
+              <a:ext uri="{FF2B5EF4-FFF2-40B4-BE49-F238E27FC236}">
+                <a16:creationId xmlns:a16="http://schemas.microsoft.com/office/drawing/2014/main" id="{44730D39-854D-3C3C-2F9A-F23A9149E7CD}"/>
+              </a:ext>
+            </a:extLst>
+          </p:cNvPr>
+          <p:cNvSpPr/>
+          <p:nvPr/>
+        </p:nvSpPr>
+        <p:spPr>
+          <a:xfrm rot="5400000">
+            <a:off x="7362398" y="620177"/>
+            <a:ext cx="482620" cy="6806367"/>
+          </a:xfrm>
+          <a:prstGeom prst="rect">
+            <a:avLst/>
+          </a:prstGeom>
+          <a:gradFill>
+            <a:gsLst>
+              <a:gs pos="0">
+                <a:schemeClr val="bg1"/>
+              </a:gs>
+              <a:gs pos="27000">
+                <a:srgbClr val="D6BBB6"/>
+              </a:gs>
+              <a:gs pos="48000">
+                <a:srgbClr val="BC8070"/>
+              </a:gs>
+              <a:gs pos="77000">
+                <a:srgbClr val="9B3215"/>
+              </a:gs>
+            </a:gsLst>
+            <a:lin ang="5400000" scaled="1"/>
+          </a:gradFill>
+          <a:ln>
+            <a:noFill/>
+          </a:ln>
+        </p:spPr>
+        <p:style>
+          <a:lnRef idx="2">
+            <a:schemeClr val="accent1">
+              <a:shade val="15000"/>
+            </a:schemeClr>
+          </a:lnRef>
+          <a:fillRef idx="1">
+            <a:schemeClr val="accent1"/>
+          </a:fillRef>
+          <a:effectRef idx="0">
+            <a:schemeClr val="accent1"/>
+          </a:effectRef>
+          <a:fontRef idx="minor">
+            <a:schemeClr val="lt1"/>
+          </a:fontRef>
+        </p:style>
+        <p:txBody>
+          <a:bodyPr rtlCol="0" anchor="ctr"/>
+          <a:lstStyle/>
+          <a:p>
+            <a:pPr algn="ctr"/>
+            <a:endParaRPr lang="en-US"/>
+          </a:p>
+        </p:txBody>
+      </p:sp>
+      <p:sp>
+        <p:nvSpPr>
+          <p:cNvPr id="14" name="Прямоугольник 13">
+            <a:extLst>
+              <a:ext uri="{FF2B5EF4-FFF2-40B4-BE49-F238E27FC236}">
+                <a16:creationId xmlns:a16="http://schemas.microsoft.com/office/drawing/2014/main" id="{C570B047-A7A2-C4C3-8B4F-1140DB70DA73}"/>
+              </a:ext>
+            </a:extLst>
+          </p:cNvPr>
+          <p:cNvSpPr/>
+          <p:nvPr/>
+        </p:nvSpPr>
+        <p:spPr>
+          <a:xfrm rot="5400000">
+            <a:off x="5690624" y="-448220"/>
+            <a:ext cx="482621" cy="3756500"/>
+          </a:xfrm>
+          <a:prstGeom prst="rect">
+            <a:avLst/>
+          </a:prstGeom>
+          <a:gradFill>
+            <a:gsLst>
+              <a:gs pos="0">
+                <a:schemeClr val="bg1"/>
+              </a:gs>
+              <a:gs pos="27000">
+                <a:srgbClr val="D6BBB6"/>
+              </a:gs>
+              <a:gs pos="48000">
+                <a:srgbClr val="BC8070"/>
+              </a:gs>
+              <a:gs pos="77000">
+                <a:srgbClr val="9B3215"/>
+              </a:gs>
+            </a:gsLst>
+            <a:lin ang="5400000" scaled="1"/>
+          </a:gradFill>
+          <a:ln>
+            <a:noFill/>
+          </a:ln>
+        </p:spPr>
+        <p:style>
+          <a:lnRef idx="2">
+            <a:schemeClr val="accent1">
+              <a:shade val="15000"/>
+            </a:schemeClr>
+          </a:lnRef>
+          <a:fillRef idx="1">
+            <a:schemeClr val="accent1"/>
+          </a:fillRef>
+          <a:effectRef idx="0">
+            <a:schemeClr val="accent1"/>
+          </a:effectRef>
+          <a:fontRef idx="minor">
+            <a:schemeClr val="lt1"/>
+          </a:fontRef>
+        </p:style>
+        <p:txBody>
+          <a:bodyPr rtlCol="0" anchor="ctr"/>
+          <a:lstStyle/>
+          <a:p>
+            <a:pPr algn="ctr"/>
+            <a:endParaRPr lang="en-US" dirty="0"/>
+          </a:p>
+        </p:txBody>
+      </p:sp>
+      <p:pic>
+        <p:nvPicPr>
+          <p:cNvPr id="12" name="Picture 4">
+            <a:extLst>
+              <a:ext uri="{FF2B5EF4-FFF2-40B4-BE49-F238E27FC236}">
+                <a16:creationId xmlns:a16="http://schemas.microsoft.com/office/drawing/2014/main" id="{8170BCCA-074E-E7F0-CDC1-266B77BF8733}"/>
+              </a:ext>
+            </a:extLst>
+          </p:cNvPr>
+          <p:cNvPicPr>
+            <a:picLocks noChangeAspect="1" noChangeArrowheads="1"/>
+          </p:cNvPicPr>
+          <p:nvPr/>
+        </p:nvPicPr>
+        <p:blipFill rotWithShape="1">
+          <a:blip r:embed="rId2">
+            <a:extLst>
+              <a:ext uri="{28A0092B-C50C-407E-A947-70E740481C1C}">
+                <a14:useLocalDpi xmlns:a14="http://schemas.microsoft.com/office/drawing/2010/main" val="0"/>
+              </a:ext>
+            </a:extLst>
+          </a:blip>
+          <a:srcRect b="17681"/>
+          <a:stretch>
+            <a:fillRect/>
+          </a:stretch>
+        </p:blipFill>
+        <p:spPr bwMode="auto">
+          <a:xfrm>
+            <a:off x="8519797" y="-5741006"/>
+            <a:ext cx="6461430" cy="8067040"/>
+          </a:xfrm>
+          <a:prstGeom prst="rect">
+            <a:avLst/>
+          </a:prstGeom>
+          <a:noFill/>
+          <a:extLst>
+            <a:ext uri="{909E8E84-426E-40DD-AFC4-6F175D3DCCD1}">
+              <a14:hiddenFill xmlns:a14="http://schemas.microsoft.com/office/drawing/2010/main">
+                <a:solidFill>
+                  <a:srgbClr val="FFFFFF"/>
+                </a:solidFill>
+              </a14:hiddenFill>
+            </a:ext>
+          </a:extLst>
+        </p:spPr>
+      </p:pic>
+      <p:pic>
+        <p:nvPicPr>
+          <p:cNvPr id="3076" name="Picture 4">
+            <a:extLst>
+              <a:ext uri="{FF2B5EF4-FFF2-40B4-BE49-F238E27FC236}">
+                <a16:creationId xmlns:a16="http://schemas.microsoft.com/office/drawing/2014/main" id="{B45424F4-82F4-D93D-E7C3-F4511131B357}"/>
+              </a:ext>
+            </a:extLst>
+          </p:cNvPr>
+          <p:cNvPicPr>
+            <a:picLocks noChangeAspect="1" noChangeArrowheads="1"/>
+          </p:cNvPicPr>
+          <p:nvPr/>
+        </p:nvPicPr>
+        <p:blipFill>
+          <a:blip r:embed="rId2">
+            <a:extLst>
+              <a:ext uri="{28A0092B-C50C-407E-A947-70E740481C1C}">
+                <a14:useLocalDpi xmlns:a14="http://schemas.microsoft.com/office/drawing/2010/main" val="0"/>
+              </a:ext>
+            </a:extLst>
+          </a:blip>
+          <a:srcRect/>
+          <a:stretch>
+            <a:fillRect/>
+          </a:stretch>
+        </p:blipFill>
+        <p:spPr bwMode="auto">
+          <a:xfrm flipH="1">
+            <a:off x="0" y="0"/>
+            <a:ext cx="4200525" cy="6858000"/>
+          </a:xfrm>
+          <a:prstGeom prst="rect">
+            <a:avLst/>
+          </a:prstGeom>
+          <a:noFill/>
+          <a:extLst>
+            <a:ext uri="{909E8E84-426E-40DD-AFC4-6F175D3DCCD1}">
+              <a14:hiddenFill xmlns:a14="http://schemas.microsoft.com/office/drawing/2010/main">
+                <a:solidFill>
+                  <a:srgbClr val="FFFFFF"/>
+                </a:solidFill>
+              </a14:hiddenFill>
+            </a:ext>
+          </a:extLst>
+        </p:spPr>
+      </p:pic>
+      <p:sp>
+        <p:nvSpPr>
+          <p:cNvPr id="2" name="TextBox 1">
+            <a:extLst>
+              <a:ext uri="{FF2B5EF4-FFF2-40B4-BE49-F238E27FC236}">
+                <a16:creationId xmlns:a16="http://schemas.microsoft.com/office/drawing/2014/main" id="{9CBC1371-AC96-EE0E-4392-BDBEC6C1B5A2}"/>
               </a:ext>
             </a:extLst>
           </p:cNvPr>
@@ -12610,8 +14673,8 @@
         </p:nvSpPr>
         <p:spPr>
           <a:xfrm>
-            <a:off x="2241633" y="5294859"/>
-            <a:ext cx="2424053" cy="369332"/>
+            <a:off x="4311711" y="3749812"/>
+            <a:ext cx="7139397" cy="2339102"/>
           </a:xfrm>
           <a:prstGeom prst="rect">
             <a:avLst/>
@@ -12625,20 +14688,72 @@
           <a:lstStyle/>
           <a:p>
             <a:r>
-              <a:rPr lang="en-US" dirty="0">
-                <a:latin typeface="GOST type A" panose="020B0500000000000000" pitchFamily="34" charset="0"/>
-              </a:rPr>
-              <a:t>https://github.com/eshsen</a:t>
-            </a:r>
+              <a:rPr lang="ru-RU" sz="2800" b="1" dirty="0">
+                <a:solidFill>
+                  <a:schemeClr val="bg1"/>
+                </a:solidFill>
+                <a:latin typeface="GOST type A" panose="020B0500000000000000" pitchFamily="34" charset="0"/>
+              </a:rPr>
+              <a:t>Качества поиска (ML)</a:t>
+            </a:r>
+          </a:p>
+          <a:p>
+            <a:endParaRPr lang="ru-RU" sz="2800" b="1" dirty="0">
+              <a:latin typeface="GOST type A" panose="020B0500000000000000" pitchFamily="34" charset="0"/>
+            </a:endParaRPr>
+          </a:p>
+          <a:p>
+            <a:pPr marL="342900" indent="-342900">
+              <a:buFont typeface="Arial" panose="020B0604020202020204" pitchFamily="34" charset="0"/>
+              <a:buChar char="•"/>
+            </a:pPr>
+            <a:r>
+              <a:rPr lang="ru-RU" sz="2400" dirty="0">
+                <a:latin typeface="GOST type A" panose="020B0500000000000000" pitchFamily="34" charset="0"/>
+              </a:rPr>
+              <a:t>Precision@5 — сколько из топ-5 действительно похожи</a:t>
+            </a:r>
+          </a:p>
+          <a:p>
+            <a:pPr marL="342900" indent="-342900">
+              <a:buFont typeface="Arial" panose="020B0604020202020204" pitchFamily="34" charset="0"/>
+              <a:buChar char="•"/>
+            </a:pPr>
+            <a:r>
+              <a:rPr lang="ru-RU" sz="2400" dirty="0">
+                <a:latin typeface="GOST type A" panose="020B0500000000000000" pitchFamily="34" charset="0"/>
+              </a:rPr>
+              <a:t>Recall@10 — сколько всех похожих нашли в топ-10</a:t>
+            </a:r>
+          </a:p>
+          <a:p>
+            <a:pPr marL="342900" indent="-342900">
+              <a:buFont typeface="Arial" panose="020B0604020202020204" pitchFamily="34" charset="0"/>
+              <a:buChar char="•"/>
+            </a:pPr>
+            <a:r>
+              <a:rPr lang="ru-RU" sz="2400" dirty="0">
+                <a:latin typeface="GOST type A" panose="020B0500000000000000" pitchFamily="34" charset="0"/>
+              </a:rPr>
+              <a:t>MRR — насколько высоко первый правильный результат</a:t>
+            </a:r>
+          </a:p>
+          <a:p>
+            <a:pPr>
+              <a:buNone/>
+            </a:pPr>
+            <a:endParaRPr lang="ru-RU" dirty="0">
+              <a:latin typeface="GOST type A" panose="020B0500000000000000" pitchFamily="34" charset="0"/>
+            </a:endParaRPr>
           </a:p>
         </p:txBody>
       </p:sp>
       <p:sp>
         <p:nvSpPr>
-          <p:cNvPr id="27" name="TextBox 26">
+          <p:cNvPr id="3" name="TextBox 2">
             <a:extLst>
               <a:ext uri="{FF2B5EF4-FFF2-40B4-BE49-F238E27FC236}">
-                <a16:creationId xmlns:a16="http://schemas.microsoft.com/office/drawing/2014/main" id="{944EF86E-29BB-0A42-8039-7E6151AC4753}"/>
+                <a16:creationId xmlns:a16="http://schemas.microsoft.com/office/drawing/2014/main" id="{5535D4C2-1D98-0E74-92BE-7F2B67DB8A20}"/>
               </a:ext>
             </a:extLst>
           </p:cNvPr>
@@ -12647,8 +14762,8 @@
         </p:nvSpPr>
         <p:spPr>
           <a:xfrm>
-            <a:off x="7343295" y="5326567"/>
-            <a:ext cx="3047035" cy="369332"/>
+            <a:off x="4236771" y="1141094"/>
+            <a:ext cx="4306529" cy="2369880"/>
           </a:xfrm>
           <a:prstGeom prst="rect">
             <a:avLst/>
@@ -12661,19 +14776,147 @@
           </a:bodyPr>
           <a:lstStyle/>
           <a:p>
-            <a:r>
-              <a:rPr lang="en-US" dirty="0">
-                <a:latin typeface="GOST type A" panose="020B0500000000000000" pitchFamily="34" charset="0"/>
-              </a:rPr>
-              <a:t>https://github.com/SollyMor</a:t>
-            </a:r>
+            <a:pPr>
+              <a:buNone/>
+            </a:pPr>
+            <a:r>
+              <a:rPr lang="ru-RU" sz="2800" b="1" dirty="0">
+                <a:solidFill>
+                  <a:schemeClr val="bg1"/>
+                </a:solidFill>
+                <a:latin typeface="GOST type A" panose="020B0500000000000000" pitchFamily="34" charset="0"/>
+              </a:rPr>
+              <a:t>Базовые</a:t>
+            </a:r>
+            <a:r>
+              <a:rPr lang="ru-RU" sz="2400" b="1" dirty="0">
+                <a:solidFill>
+                  <a:schemeClr val="bg1"/>
+                </a:solidFill>
+                <a:latin typeface="GOST type A" panose="020B0500000000000000" pitchFamily="34" charset="0"/>
+              </a:rPr>
+              <a:t> </a:t>
+            </a:r>
+          </a:p>
+          <a:p>
+            <a:pPr>
+              <a:buNone/>
+            </a:pPr>
+            <a:endParaRPr lang="ru-RU" sz="2400" b="1" dirty="0">
+              <a:latin typeface="GOST type A" panose="020B0500000000000000" pitchFamily="34" charset="0"/>
+            </a:endParaRPr>
+          </a:p>
+          <a:p>
+            <a:pPr marL="342900" indent="-342900">
+              <a:buFont typeface="Arial" panose="020B0604020202020204" pitchFamily="34" charset="0"/>
+              <a:buChar char="•"/>
+            </a:pPr>
+            <a:r>
+              <a:rPr lang="ru-RU" sz="2400" dirty="0">
+                <a:latin typeface="GOST type A" panose="020B0500000000000000" pitchFamily="34" charset="0"/>
+              </a:rPr>
+              <a:t> Количество запросов в день</a:t>
+            </a:r>
+          </a:p>
+          <a:p>
+            <a:pPr marL="342900" indent="-342900">
+              <a:buFont typeface="Arial" panose="020B0604020202020204" pitchFamily="34" charset="0"/>
+              <a:buChar char="•"/>
+            </a:pPr>
+            <a:r>
+              <a:rPr lang="ru-RU" sz="2400" dirty="0">
+                <a:latin typeface="GOST type A" panose="020B0500000000000000" pitchFamily="34" charset="0"/>
+              </a:rPr>
+              <a:t> Средняя длительность сессии</a:t>
+            </a:r>
+          </a:p>
+          <a:p>
+            <a:pPr marL="342900" indent="-342900">
+              <a:buFont typeface="Arial" panose="020B0604020202020204" pitchFamily="34" charset="0"/>
+              <a:buChar char="•"/>
+            </a:pPr>
+            <a:r>
+              <a:rPr lang="ru-RU" sz="2400" dirty="0">
+                <a:latin typeface="GOST type A" panose="020B0500000000000000" pitchFamily="34" charset="0"/>
+              </a:rPr>
+              <a:t> Самые частые поисковые запросы (какие иероглифы ищут)</a:t>
+            </a:r>
+          </a:p>
+        </p:txBody>
+      </p:sp>
+      <p:sp>
+        <p:nvSpPr>
+          <p:cNvPr id="5" name="TextBox 4">
+            <a:extLst>
+              <a:ext uri="{FF2B5EF4-FFF2-40B4-BE49-F238E27FC236}">
+                <a16:creationId xmlns:a16="http://schemas.microsoft.com/office/drawing/2014/main" id="{63F0A2C5-EF02-3FAB-E9BC-5CB0D47A5EF1}"/>
+              </a:ext>
+            </a:extLst>
+          </p:cNvPr>
+          <p:cNvSpPr txBox="1"/>
+          <p:nvPr/>
+        </p:nvSpPr>
+        <p:spPr>
+          <a:xfrm>
+            <a:off x="3371193" y="-171986"/>
+            <a:ext cx="556571" cy="7201972"/>
+          </a:xfrm>
+          <a:prstGeom prst="rect">
+            <a:avLst/>
+          </a:prstGeom>
+          <a:noFill/>
+        </p:spPr>
+        <p:txBody>
+          <a:bodyPr wrap="square">
+            <a:spAutoFit/>
+          </a:bodyPr>
+          <a:lstStyle/>
+          <a:p>
+            <a:pPr algn="ctr"/>
+            <a:r>
+              <a:rPr lang="ru-RU" sz="6600" b="1" dirty="0">
+                <a:ln w="3175" cap="rnd">
+                  <a:solidFill>
+                    <a:schemeClr val="bg1"/>
+                  </a:solidFill>
+                </a:ln>
+                <a:effectLst>
+                  <a:glow>
+                    <a:schemeClr val="accent1">
+                      <a:alpha val="40000"/>
+                    </a:schemeClr>
+                  </a:glow>
+                  <a:reflection endPos="0" dist="50800" dir="5400000" sy="-100000" algn="bl" rotWithShape="0"/>
+                </a:effectLst>
+                <a:latin typeface="GOST type A" panose="020B0500000000000000" pitchFamily="34" charset="0"/>
+                <a:ea typeface="MS PGothic" panose="020B0600070205080204" pitchFamily="34" charset="-128"/>
+              </a:rPr>
+              <a:t>Метрики</a:t>
+            </a:r>
+            <a:endParaRPr lang="en-US" sz="6600" b="1" dirty="0">
+              <a:ln w="3175" cap="rnd">
+                <a:solidFill>
+                  <a:schemeClr val="bg1"/>
+                </a:solidFill>
+              </a:ln>
+              <a:effectLst>
+                <a:glow>
+                  <a:schemeClr val="accent1">
+                    <a:alpha val="40000"/>
+                  </a:schemeClr>
+                </a:glow>
+                <a:reflection endPos="0" dist="50800" dir="5400000" sy="-100000" algn="bl" rotWithShape="0"/>
+              </a:effectLst>
+              <a:latin typeface="GOST type A" panose="020B0500000000000000" pitchFamily="34" charset="0"/>
+              <a:ea typeface="MS PGothic" panose="020B0600070205080204" pitchFamily="34" charset="-128"/>
+            </a:endParaRPr>
           </a:p>
         </p:txBody>
       </p:sp>
     </p:spTree>
     <p:extLst>
       <p:ext uri="{BB962C8B-B14F-4D97-AF65-F5344CB8AC3E}">
-        <p14:creationId xmlns:p14="http://schemas.microsoft.com/office/powerpoint/2010/main" val="2811943427"/>
+        <p14:creationId xmlns:p14="http://schemas.microsoft.com/office/powerpoint/2010/main" val="2543309436"/>
       </p:ext>
     </p:extLst>
   </p:cSld>

</xml_diff>